<commit_message>
Update slides 11 and 15: public HTTPS deployment complete
Dashboard is live on Streamlit Community Cloud, backed by a public
Neon PostgreSQL instance seeded with the real pipeline data.

Co-Authored-By: Claude Sonnet 5 <noreply@anthropic.com>
</commit_message>
<xml_diff>
--- a/slides/pos_pipeline_presentation.pptx
+++ b/slides/pos_pipeline_presentation.pptx
@@ -3983,12 +3983,12 @@
         </p:nvSpPr>
         <p:spPr>
           <a:xfrm>
-            <a:off x="548640" y="1828800"/>
-            <a:ext cx="11064240" cy="1051560"/>
+            <a:off x="548640" y="1691640"/>
+            <a:ext cx="11064240" cy="914400"/>
           </a:xfrm>
           <a:prstGeom prst="roundRect">
             <a:avLst>
-              <a:gd name="adj" fmla="val 6957"/>
+              <a:gd name="adj" fmla="val 8000"/>
             </a:avLst>
           </a:prstGeom>
           <a:solidFill>
@@ -4005,7 +4005,7 @@
         </p:nvSpPr>
         <p:spPr>
           <a:xfrm>
-            <a:off x="822960" y="2121408"/>
+            <a:off x="822960" y="1920240"/>
             <a:ext cx="457200" cy="457200"/>
           </a:xfrm>
           <a:prstGeom prst="ellipse">
@@ -4025,7 +4025,7 @@
         </p:nvSpPr>
         <p:spPr>
           <a:xfrm>
-            <a:off x="822960" y="2121408"/>
+            <a:off x="822960" y="1920240"/>
             <a:ext cx="457200" cy="457200"/>
           </a:xfrm>
           <a:prstGeom prst="rect">
@@ -4064,8 +4064,8 @@
         </p:nvSpPr>
         <p:spPr>
           <a:xfrm>
-            <a:off x="1508760" y="1938528"/>
-            <a:ext cx="3657600" cy="822960"/>
+            <a:off x="1508760" y="1764792"/>
+            <a:ext cx="3657600" cy="777240"/>
           </a:xfrm>
           <a:prstGeom prst="rect">
             <a:avLst/>
@@ -4103,8 +4103,8 @@
         </p:nvSpPr>
         <p:spPr>
           <a:xfrm>
-            <a:off x="5257800" y="1938528"/>
-            <a:ext cx="4114800" cy="822960"/>
+            <a:off x="5257800" y="1764792"/>
+            <a:ext cx="4206240" cy="777240"/>
           </a:xfrm>
           <a:prstGeom prst="rect">
             <a:avLst/>
@@ -4142,8 +4142,8 @@
         </p:nvSpPr>
         <p:spPr>
           <a:xfrm>
-            <a:off x="9464040" y="1938528"/>
-            <a:ext cx="2057400" cy="822960"/>
+            <a:off x="9555480" y="1764792"/>
+            <a:ext cx="1965960" cy="777240"/>
           </a:xfrm>
           <a:prstGeom prst="rect">
             <a:avLst/>
@@ -4159,7 +4159,7 @@
               <a:buNone/>
             </a:pPr>
             <a:r>
-              <a:rPr lang="en-US" sz="1100" b="1" dirty="0">
+              <a:rPr lang="en-US" sz="1150" b="1" dirty="0">
                 <a:solidFill>
                   <a:srgbClr val="1E2761"/>
                 </a:solidFill>
@@ -4167,9 +4167,9 @@
                 <a:ea typeface="Calibri" pitchFamily="34" charset="-122"/>
                 <a:cs typeface="Calibri" pitchFamily="34" charset="-120"/>
               </a:rPr>
-              <a:t>เสร็จสมบูรณ์ — ทดสอบ Local ผ่าน</a:t>
-            </a:r>
-            <a:endParaRPr lang="en-US" sz="1100" dirty="0"/>
+              <a:t>เสร็จสมบูรณ์</a:t>
+            </a:r>
+            <a:endParaRPr lang="en-US" sz="1150" dirty="0"/>
           </a:p>
         </p:txBody>
       </p:sp>
@@ -4181,12 +4181,12 @@
         </p:nvSpPr>
         <p:spPr>
           <a:xfrm>
-            <a:off x="548640" y="3063240"/>
-            <a:ext cx="11064240" cy="1051560"/>
+            <a:off x="548640" y="2770632"/>
+            <a:ext cx="11064240" cy="914400"/>
           </a:xfrm>
           <a:prstGeom prst="roundRect">
             <a:avLst>
-              <a:gd name="adj" fmla="val 6957"/>
+              <a:gd name="adj" fmla="val 8000"/>
             </a:avLst>
           </a:prstGeom>
           <a:solidFill>
@@ -4203,7 +4203,7 @@
         </p:nvSpPr>
         <p:spPr>
           <a:xfrm>
-            <a:off x="822960" y="3355848"/>
+            <a:off x="822960" y="2999232"/>
             <a:ext cx="457200" cy="457200"/>
           </a:xfrm>
           <a:prstGeom prst="ellipse">
@@ -4223,7 +4223,7 @@
         </p:nvSpPr>
         <p:spPr>
           <a:xfrm>
-            <a:off x="822960" y="3355848"/>
+            <a:off x="822960" y="2999232"/>
             <a:ext cx="457200" cy="457200"/>
           </a:xfrm>
           <a:prstGeom prst="rect">
@@ -4262,8 +4262,8 @@
         </p:nvSpPr>
         <p:spPr>
           <a:xfrm>
-            <a:off x="1508760" y="3172968"/>
-            <a:ext cx="3657600" cy="822960"/>
+            <a:off x="1508760" y="2843784"/>
+            <a:ext cx="3657600" cy="777240"/>
           </a:xfrm>
           <a:prstGeom prst="rect">
             <a:avLst/>
@@ -4287,7 +4287,7 @@
                 <a:ea typeface="Calibri" pitchFamily="34" charset="-122"/>
                 <a:cs typeface="Calibri" pitchFamily="34" charset="-120"/>
               </a:rPr>
-              <a:t>Local Verification</a:t>
+              <a:t>Public Database</a:t>
             </a:r>
             <a:endParaRPr lang="en-US" sz="1400" dirty="0"/>
           </a:p>
@@ -4301,8 +4301,8 @@
         </p:nvSpPr>
         <p:spPr>
           <a:xfrm>
-            <a:off x="5257800" y="3172968"/>
-            <a:ext cx="4114800" cy="822960"/>
+            <a:off x="5257800" y="2843784"/>
+            <a:ext cx="4206240" cy="777240"/>
           </a:xfrm>
           <a:prstGeom prst="rect">
             <a:avLst/>
@@ -4326,7 +4326,7 @@
                 <a:ea typeface="Calibri" pitchFamily="34" charset="-122"/>
                 <a:cs typeface="Calibri" pitchFamily="34" charset="-120"/>
               </a:rPr>
-              <a:t>streamlit run app.py — ต่อ Postgres จริง</a:t>
+              <a:t>PostgreSQL บน Neon (Serverless) — migrate ข้อมูลจริง 542 แถว</a:t>
             </a:r>
             <a:endParaRPr lang="en-US" sz="1150" dirty="0"/>
           </a:p>
@@ -4340,8 +4340,8 @@
         </p:nvSpPr>
         <p:spPr>
           <a:xfrm>
-            <a:off x="9464040" y="3172968"/>
-            <a:ext cx="2057400" cy="822960"/>
+            <a:off x="9555480" y="2843784"/>
+            <a:ext cx="1965960" cy="777240"/>
           </a:xfrm>
           <a:prstGeom prst="rect">
             <a:avLst/>
@@ -4357,7 +4357,7 @@
               <a:buNone/>
             </a:pPr>
             <a:r>
-              <a:rPr lang="en-US" sz="1100" b="1" dirty="0">
+              <a:rPr lang="en-US" sz="1150" b="1" dirty="0">
                 <a:solidFill>
                   <a:srgbClr val="1E2761"/>
                 </a:solidFill>
@@ -4365,9 +4365,9 @@
                 <a:ea typeface="Calibri" pitchFamily="34" charset="-122"/>
                 <a:cs typeface="Calibri" pitchFamily="34" charset="-120"/>
               </a:rPr>
-              <a:t>เสร็จสมบูรณ์ — ยืนยันด้วย Screenshot</a:t>
-            </a:r>
-            <a:endParaRPr lang="en-US" sz="1100" dirty="0"/>
+              <a:t>เสร็จสมบูรณ์</a:t>
+            </a:r>
+            <a:endParaRPr lang="en-US" sz="1150" dirty="0"/>
           </a:p>
         </p:txBody>
       </p:sp>
@@ -4379,12 +4379,12 @@
         </p:nvSpPr>
         <p:spPr>
           <a:xfrm>
-            <a:off x="548640" y="4297680"/>
-            <a:ext cx="11064240" cy="1051560"/>
+            <a:off x="548640" y="3849624"/>
+            <a:ext cx="11064240" cy="914400"/>
           </a:xfrm>
           <a:prstGeom prst="roundRect">
             <a:avLst>
-              <a:gd name="adj" fmla="val 6957"/>
+              <a:gd name="adj" fmla="val 8000"/>
             </a:avLst>
           </a:prstGeom>
           <a:solidFill>
@@ -4401,14 +4401,14 @@
         </p:nvSpPr>
         <p:spPr>
           <a:xfrm>
-            <a:off x="822960" y="4590288"/>
+            <a:off x="822960" y="4078224"/>
             <a:ext cx="457200" cy="457200"/>
           </a:xfrm>
           <a:prstGeom prst="ellipse">
             <a:avLst/>
           </a:prstGeom>
           <a:solidFill>
-            <a:srgbClr val="B3261E"/>
+            <a:srgbClr val="1E2761"/>
           </a:solidFill>
           <a:ln/>
         </p:spPr>
@@ -4421,7 +4421,7 @@
         </p:nvSpPr>
         <p:spPr>
           <a:xfrm>
-            <a:off x="822960" y="4590288"/>
+            <a:off x="822960" y="4078224"/>
             <a:ext cx="457200" cy="457200"/>
           </a:xfrm>
           <a:prstGeom prst="rect">
@@ -4446,7 +4446,7 @@
                 <a:ea typeface="Calibri" pitchFamily="34" charset="-122"/>
                 <a:cs typeface="Calibri" pitchFamily="34" charset="-120"/>
               </a:rPr>
-              <a:t>!</a:t>
+              <a:t>✓</a:t>
             </a:r>
             <a:endParaRPr lang="en-US" sz="1600" dirty="0"/>
           </a:p>
@@ -4460,8 +4460,8 @@
         </p:nvSpPr>
         <p:spPr>
           <a:xfrm>
-            <a:off x="1508760" y="4407408"/>
-            <a:ext cx="3657600" cy="822960"/>
+            <a:off x="1508760" y="3922776"/>
+            <a:ext cx="3657600" cy="777240"/>
           </a:xfrm>
           <a:prstGeom prst="rect">
             <a:avLst/>
@@ -4499,8 +4499,8 @@
         </p:nvSpPr>
         <p:spPr>
           <a:xfrm>
-            <a:off x="5257800" y="4407408"/>
-            <a:ext cx="4114800" cy="822960"/>
+            <a:off x="5257800" y="3922776"/>
+            <a:ext cx="4206240" cy="777240"/>
           </a:xfrm>
           <a:prstGeom prst="rect">
             <a:avLst/>
@@ -4524,7 +4524,7 @@
                 <a:ea typeface="Calibri" pitchFamily="34" charset="-122"/>
                 <a:cs typeface="Calibri" pitchFamily="34" charset="-120"/>
               </a:rPr>
-              <a:t>Streamlit Community Cloud + GitHub Repo</a:t>
+              <a:t>Streamlit Community Cloud เชื่อมกับ GitHub Repo</a:t>
             </a:r>
             <a:endParaRPr lang="en-US" sz="1150" dirty="0"/>
           </a:p>
@@ -4538,8 +4538,8 @@
         </p:nvSpPr>
         <p:spPr>
           <a:xfrm>
-            <a:off x="9464040" y="4407408"/>
-            <a:ext cx="2057400" cy="822960"/>
+            <a:off x="9555480" y="3922776"/>
+            <a:ext cx="1965960" cy="777240"/>
           </a:xfrm>
           <a:prstGeom prst="rect">
             <a:avLst/>
@@ -4555,30 +4555,52 @@
               <a:buNone/>
             </a:pPr>
             <a:r>
-              <a:rPr lang="en-US" sz="1100" b="1" dirty="0">
-                <a:solidFill>
-                  <a:srgbClr val="B3261E"/>
+              <a:rPr lang="en-US" sz="1150" b="1" dirty="0">
+                <a:solidFill>
+                  <a:srgbClr val="1E2761"/>
                 </a:solidFill>
                 <a:latin typeface="Calibri" pitchFamily="34" charset="0"/>
                 <a:ea typeface="Calibri" pitchFamily="34" charset="-122"/>
                 <a:cs typeface="Calibri" pitchFamily="34" charset="-120"/>
               </a:rPr>
-              <a:t>ขั้นตอนถัดไป — ต้องใช้บัญชีส่วนตัว</a:t>
-            </a:r>
-            <a:endParaRPr lang="en-US" sz="1100" dirty="0"/>
-          </a:p>
-        </p:txBody>
-      </p:sp>
-      <p:sp>
-        <p:nvSpPr>
-          <p:cNvPr id="22" name="Text 20"/>
-          <p:cNvSpPr txBox="1"/>
-          <p:nvPr/>
-        </p:nvSpPr>
-        <p:spPr>
-          <a:xfrm>
-            <a:off x="548640" y="6492240"/>
-            <a:ext cx="8229600" cy="274320"/>
+              <a:t>เสร็จสมบูรณ์ — Live</a:t>
+            </a:r>
+            <a:endParaRPr lang="en-US" sz="1150" dirty="0"/>
+          </a:p>
+        </p:txBody>
+      </p:sp>
+      <p:sp>
+        <p:nvSpPr>
+          <p:cNvPr id="22" name="Shape 20"/>
+          <p:cNvSpPr/>
+          <p:nvPr/>
+        </p:nvSpPr>
+        <p:spPr>
+          <a:xfrm>
+            <a:off x="548640" y="4892040"/>
+            <a:ext cx="11064240" cy="1097280"/>
+          </a:xfrm>
+          <a:prstGeom prst="roundRect">
+            <a:avLst>
+              <a:gd name="adj" fmla="val 6667"/>
+            </a:avLst>
+          </a:prstGeom>
+          <a:solidFill>
+            <a:srgbClr val="1E2761"/>
+          </a:solidFill>
+          <a:ln/>
+        </p:spPr>
+      </p:sp>
+      <p:sp>
+        <p:nvSpPr>
+          <p:cNvPr id="23" name="Text 21"/>
+          <p:cNvSpPr txBox="1"/>
+          <p:nvPr/>
+        </p:nvSpPr>
+        <p:spPr>
+          <a:xfrm>
+            <a:off x="822960" y="5029200"/>
+            <a:ext cx="5486400" cy="365760"/>
           </a:xfrm>
           <a:prstGeom prst="rect">
             <a:avLst/>
@@ -4594,15 +4616,93 @@
               <a:buNone/>
             </a:pPr>
             <a:r>
-              <a:rPr lang="en-US" sz="900" dirty="0">
-                <a:solidFill>
-                  <a:srgbClr val="5B6472"/>
+              <a:rPr lang="en-US" sz="1200" b="1" spc="150" kern="0" dirty="0">
+                <a:solidFill>
+                  <a:srgbClr val="CADCFC"/>
                 </a:solidFill>
                 <a:latin typeface="Calibri" pitchFamily="34" charset="0"/>
                 <a:ea typeface="Calibri" pitchFamily="34" charset="-122"/>
                 <a:cs typeface="Calibri" pitchFamily="34" charset="-120"/>
               </a:rPr>
-              <a:t>แผน: push โค้ดขึ้น GitHub → เชื่อม Streamlit Community Cloud → ตั้งค่า DATABASE_URL เป็น secret → ได้โดเมน HTTPS ฟรี</a:t>
+              <a:t>LIVE DASHBOARD URL</a:t>
+            </a:r>
+            <a:endParaRPr lang="en-US" sz="1200" dirty="0"/>
+          </a:p>
+        </p:txBody>
+      </p:sp>
+      <p:sp>
+        <p:nvSpPr>
+          <p:cNvPr id="24" name="Text 22"/>
+          <p:cNvSpPr txBox="1"/>
+          <p:nvPr/>
+        </p:nvSpPr>
+        <p:spPr>
+          <a:xfrm>
+            <a:off x="822960" y="5349240"/>
+            <a:ext cx="10515600" cy="502920"/>
+          </a:xfrm>
+          <a:prstGeom prst="rect">
+            <a:avLst/>
+          </a:prstGeom>
+          <a:noFill/>
+          <a:ln/>
+        </p:spPr>
+        <p:txBody>
+          <a:bodyPr wrap="square" lIns="0" tIns="0" rIns="0" bIns="0" rtlCol="0" anchor="ctr"/>
+          <a:lstStyle/>
+          <a:p>
+            <a:pPr indent="0" marL="0">
+              <a:buNone/>
+            </a:pPr>
+            <a:r>
+              <a:rPr lang="en-US" sz="1700" b="1" dirty="0">
+                <a:solidFill>
+                  <a:srgbClr val="FFFFFF"/>
+                </a:solidFill>
+                <a:latin typeface="Courier New" pitchFamily="34" charset="0"/>
+                <a:ea typeface="Courier New" pitchFamily="34" charset="-122"/>
+                <a:cs typeface="Courier New" pitchFamily="34" charset="-120"/>
+              </a:rPr>
+              <a:t>pos-anomaly-pipeline-duga3in95l2i7apb78xzee.streamlit.app</a:t>
+            </a:r>
+            <a:endParaRPr lang="en-US" sz="1700" dirty="0"/>
+          </a:p>
+        </p:txBody>
+      </p:sp>
+      <p:sp>
+        <p:nvSpPr>
+          <p:cNvPr id="25" name="Text 23"/>
+          <p:cNvSpPr txBox="1"/>
+          <p:nvPr/>
+        </p:nvSpPr>
+        <p:spPr>
+          <a:xfrm>
+            <a:off x="548640" y="6492240"/>
+            <a:ext cx="8229600" cy="274320"/>
+          </a:xfrm>
+          <a:prstGeom prst="rect">
+            <a:avLst/>
+          </a:prstGeom>
+          <a:noFill/>
+          <a:ln/>
+        </p:spPr>
+        <p:txBody>
+          <a:bodyPr wrap="square" lIns="0" tIns="0" rIns="0" bIns="0" rtlCol="0" anchor="ctr"/>
+          <a:lstStyle/>
+          <a:p>
+            <a:pPr indent="0" marL="0">
+              <a:buNone/>
+            </a:pPr>
+            <a:r>
+              <a:rPr lang="en-US" sz="900" dirty="0">
+                <a:solidFill>
+                  <a:srgbClr val="5B6472"/>
+                </a:solidFill>
+                <a:latin typeface="Calibri" pitchFamily="34" charset="0"/>
+                <a:ea typeface="Calibri" pitchFamily="34" charset="-122"/>
+                <a:cs typeface="Calibri" pitchFamily="34" charset="-120"/>
+              </a:rPr>
+              <a:t>Architecture: GitHub (source) → Streamlit Community Cloud (hosting + HTTPS) → Neon PostgreSQL (public serverless DB) — ข้อมูลจาก local pipeline ถูก migrate ขึ้นจริง</a:t>
             </a:r>
             <a:endParaRPr lang="en-US" sz="900" dirty="0"/>
           </a:p>
@@ -9397,7 +9497,7 @@
                 <a:ea typeface="Calibri" pitchFamily="34" charset="-122"/>
                 <a:cs typeface="Calibri" pitchFamily="34" charset="-120"/>
               </a:rPr>
-              <a:t>Dashboard ทำงานสมบูรณ์ (Local) · รอ Deploy HTTPS Domain สาธารณะ</a:t>
+              <a:t>Live บน Streamlit Cloud ผ่าน HTTPS จริง · Neon PostgreSQL สาธารณะ</a:t>
             </a:r>
             <a:endParaRPr lang="en-US" sz="1150" dirty="0"/>
           </a:p>

</xml_diff>

<commit_message>
Add speaker notes to every slide
Plain-Thai spoken script per slide so the presentation can be
delivered by reading the notes directly, matching the demo script.

Co-Authored-By: Claude Sonnet 5 <noreply@anthropic.com>
</commit_message>
<xml_diff>
--- a/slides/pos_pipeline_presentation.pptx
+++ b/slides/pos_pipeline_presentation.pptx
@@ -1121,7 +1121,7 @@
           <a:p>
             <a:r>
               <a:rPr lang="en-US" dirty="0"/>
-              <a:t/>
+              <a:t>สวัสดีครับ ผมชื่อนายกันต์กวี รามศรี รหัสนักศึกษา 6900102365 วันนี้จะมานำเสนองาน Real-Time Data Pipeline Architecture และระบบตรวจจับความผิดปกติสำหรับระบบ POS ขององค์กรครับ โดยจะครอบคลุมทั้ง 4 Task ตามที่โจทย์กำหนด</a:t>
             </a:r>
             <a:endParaRPr lang="en-US" dirty="0"/>
           </a:p>
@@ -1209,7 +1209,7 @@
           <a:p>
             <a:r>
               <a:rPr lang="en-US" dirty="0"/>
-              <a:t/>
+              <a:t>มาที่ Task 3 ครับ ผมสร้าง Dashboard ด้วย Streamlit ที่ดึงข้อมูลจาก PostgreSQL มาแสดงแบบสด กราฟนี้เป็นข้อมูลจริงจากฐานข้อมูล จะเห็น Flash Sale ที่ทำให้ยอดขายพุ่งขึ้นชัดเจนมาก นอกจากยอดขายรวมแล้ว Dashboard ยังคำนวณค่าเฉลี่ยเคลื่อนที่หรือ Moving Average ซ้อนบนกราฟ และไฮไลต์รายการที่ผิดปกติด้วยสีแดงในตารางด้านล่างด้วยครับ</a:t>
             </a:r>
             <a:endParaRPr lang="en-US" dirty="0"/>
           </a:p>
@@ -1297,7 +1297,7 @@
           <a:p>
             <a:r>
               <a:rPr lang="en-US" dirty="0"/>
-              <a:t/>
+              <a:t>และที่สำคัญคือ Dashboard นี้ไม่ได้รันอยู่แค่ในเครื่องผมนะครับ แต่ผม deploy ขึ้นไปจริงแล้ว โดยใช้ Streamlit Community Cloud เชื่อมกับ GitHub repository และย้ายฐานข้อมูลไปไว้บน Neon ซึ่งเป็น PostgreSQL แบบสาธารณะ ตอนนี้ใครก็เข้าดูผ่านลิงก์ HTTPS นี้ได้เลยครับ ทุกส่วนของ Task 3 เสร็จสมบูรณ์ตามเกณฑ์ที่โจทย์กำหนด</a:t>
             </a:r>
             <a:endParaRPr lang="en-US" dirty="0"/>
           </a:p>
@@ -1385,7 +1385,7 @@
           <a:p>
             <a:r>
               <a:rPr lang="en-US" dirty="0"/>
-              <a:t/>
+              <a:t>ต่อมาคือ Task 4 ครับ ผมต้องการเปรียบเทียบว่า sensor สามแบบที่พูดถึงก่อนหน้านี้ ต่างกันแค่ไหนจริงๆ เลยเขียน DAG สามตัวที่เหมือนกันทุกอย่าง ต่างกันแค่โหมดของ sensor แล้ววัดผลจริงโดยดู state ของ task และ resource การใช้งาน CPU ของ container ในช่วงที่ sensor กำลังรออยู่ ทุกอย่างรันจริงบน docker-compose stack ของโปรเจกต์นี้ครับ ไม่ใช่ผลจำลอง</a:t>
             </a:r>
             <a:endParaRPr lang="en-US" dirty="0"/>
           </a:p>
@@ -1473,7 +1473,7 @@
           <a:p>
             <a:r>
               <a:rPr lang="en-US" dirty="0"/>
-              <a:t/>
+              <a:t>นี่คือผลลัพธ์จริงที่วัดได้ครับ จะเห็นว่า state ของ task ตรงตามที่ออกแบบไว้ทุกโหมด — poke จะค้างอยู่ที่ running ตลอด, reschedule จะสลับไปมา, ส่วน deferrable จะไปอยู่ที่ deferred ซึ่งหมายความว่าไม่ได้ครอบครอง worker slot เลย ส่วนตัวเลข CPU ผมขอเรียนตรงๆ ว่ายังไม่ใช่ตัวชี้วัดที่แม่นยำนักที่ scale เล็กแบบนี้ เพราะมันถูกรบกวนจาก housekeeping ของ Airflow เอง แต่ state ของ task คือหลักฐานที่ชัดเจนที่สุดครับ</a:t>
             </a:r>
             <a:endParaRPr lang="en-US" dirty="0"/>
           </a:p>
@@ -1561,7 +1561,7 @@
           <a:p>
             <a:r>
               <a:rPr lang="en-US" dirty="0"/>
-              <a:t/>
+              <a:t>สุดท้ายผมเขียนข้อเสนอว่า ถ้าระบบต้องขยายไปรองรับ 10,000 transaction ต่อวินาที จะต้องเปลี่ยนอะไรบ้าง เพราะระบบปัจจุบันที่ใช้การรับไฟล์แบบ batch จะรับมือไม่ไหวแน่นอน สิ่งที่ต้องเปลี่ยนหลักๆ คือเปลี่ยนจากการรับไฟล์เป็น Apache Kafka ที่รับข้อมูลแบบ stream ต่อเนื่อง เปลี่ยนจาก Airflow batch DAG เป็นตัวประมวลผลแบบ Flink หรือ Kafka Streams ที่ทำงานต่อเนื่องตลอดเวลา และเปลี่ยนฐานข้อมูลจาก PostgreSQL แบบ row-store เป็นฐานข้อมูลแบบ Columnar อย่าง ClickHouse ที่เหมาะกับงานวิเคราะห์ข้อมูลปริมาณมากครับ</a:t>
             </a:r>
             <a:endParaRPr lang="en-US" dirty="0"/>
           </a:p>
@@ -1649,7 +1649,7 @@
           <a:p>
             <a:r>
               <a:rPr lang="en-US" dirty="0"/>
-              <a:t/>
+              <a:t>สรุปภาพรวมทั้งหมดเทียบกับเกณฑ์การประเมินนะครับ — ด้าน System Resilience ผมพิสูจน์ Idempotency ด้วยการทดสอบจริง ด้าน Airflow Architecture ผมใช้ Deferrable Operator ร่วมกับ TaskFlow API และยืนยัน state จริงตรงตามที่ออกแบบ ด้านรายงานผมมีผลการทดสอบเชิงตัวเลขจริงพร้อมข้อเสนอขยายระบบ และด้าน Dashboard ผม deploy ขึ้นสู่สาธารณะผ่าน HTTPS เรียบร้อยแล้วครับ</a:t>
             </a:r>
             <a:endParaRPr lang="en-US" dirty="0"/>
           </a:p>
@@ -1737,7 +1737,7 @@
           <a:p>
             <a:r>
               <a:rPr lang="en-US" dirty="0"/>
-              <a:t/>
+              <a:t>งานนี้ผมตั้งใจทำให้ทุกส่วนรันได้จริง ไม่ใช่แค่ทฤษฎีครับ ขอบคุณที่รับชมครับ หากมีคำถามยินดีตอบครับ</a:t>
             </a:r>
             <a:endParaRPr lang="en-US" dirty="0"/>
           </a:p>
@@ -1825,7 +1825,7 @@
           <a:p>
             <a:r>
               <a:rPr lang="en-US" dirty="0"/>
-              <a:t/>
+              <a:t>ก่อนเข้าเนื้อหา ขอสรุปภาพรวมก่อนนะครับ งานนี้แบ่งเป็น 4 ส่วน — Task 1 คือการจำลองข้อมูลการขายและสถานการณ์ผิดปกติ, Task 2 คือระบบดึงข้อมูลอัตโนมัติด้วย Airflow ที่ทนทานต่อความผิดพลาด, Task 3 คือ Dashboard แสดงผลแบบสด, และ Task 4 คือรายงานเปรียบเทียบประสิทธิภาพพร้อมข้อเสนอขยายระบบ</a:t>
             </a:r>
             <a:endParaRPr lang="en-US" dirty="0"/>
           </a:p>
@@ -1913,7 +1913,7 @@
           <a:p>
             <a:r>
               <a:rPr lang="en-US" dirty="0"/>
-              <a:t/>
+              <a:t>นี่คือภาพรวมของทั้งระบบครับ เริ่มจาก Workload Generator ที่จำลองข้อมูลการขาย ส่งเป็นไฟล์ไปวางไว้ที่ Landing Directory จากนั้น Airflow DAG จะคอยตรวจจับไฟล์ใหม่ ดึงเข้ามาตรวจสอบแล้วบันทึกลง PostgreSQL แล้วข้อมูลนี้จะถูกนำไปแสดงผลใน Dashboard และถ้าเจอความผิดปกติ ระบบจะส่งการแจ้งเตือนแยกออกไปอีกทางหนึ่งด้วยครับ ทุกขั้นตอนถูกออกแบบให้ Idempotent คือรันซ้ำกี่ครั้งข้อมูลก็ไม่ซ้ำซ้อน ซึ่งผมทดสอบจริงแล้วครับ</a:t>
             </a:r>
             <a:endParaRPr lang="en-US" dirty="0"/>
           </a:p>
@@ -2001,7 +2001,7 @@
           <a:p>
             <a:r>
               <a:rPr lang="en-US" dirty="0"/>
-              <a:t/>
+              <a:t>เริ่มที่ Task 1 ครับ ผมเขียน Python script ขึ้นมาจำลองสถานการณ์จริงของร้าน POS สี่แบบ — อย่างแรกคือ Flash Sale ยอดขายพุ่งขึ้น 10 เท่าในช่วงเวลาสั้นๆ, อย่างที่สองคือข้อมูลมาช้ากว่าเวลาจริง เหมือนเครื่อง POS เน็ตหลุดแล้วข้อมูลมาทีหลัง, อย่างที่สามคือรายการซื้อขายซ้ำ เหมือนบิลเดียวกันถูกส่งเข้ามาสองรอบ, และสุดท้ายคือยอดเงินติดลบ ซึ่งเป็นข้อมูลที่ผิดปกติไม่ควรเกิดขึ้นจริง</a:t>
             </a:r>
             <a:endParaRPr lang="en-US" dirty="0"/>
           </a:p>
@@ -2089,7 +2089,7 @@
           <a:p>
             <a:r>
               <a:rPr lang="en-US" dirty="0"/>
-              <a:t/>
+              <a:t>ผมรัน script นี้จริงบนเครื่อง ได้ผลลัพธ์ตามกราฟนี้ครับ จะเห็นว่าช่วง Flash Sale อัตราการส่งข้อมูลพุ่งขึ้นจาก 10 เป็น 100 records ต่อ batch คือ 10 เท่าตามที่ออกแบบไว้พอดี รวมทั้งหมดสร้างข้อมูลไป 560 รายการ มีความผิดปกติที่ inject เข้าไปโดยตั้งใจ 62 รายการ</a:t>
             </a:r>
             <a:endParaRPr lang="en-US" dirty="0"/>
           </a:p>
@@ -2177,7 +2177,7 @@
           <a:p>
             <a:r>
               <a:rPr lang="en-US" dirty="0"/>
-              <a:t/>
+              <a:t>มาถึง Task 2 ซึ่งเป็นส่วนที่ผมให้ความสำคัญมากที่สุด เพราะเป็นหัวใจของระบบ Ingestion Pipeline นี้ผมออกแบบด้วย TaskFlow API ของ Airflow ตามมาตรฐาน Clean Code มีสี่ feature หลักคือ Deferrable Operator, TaskFlow API กับ XCom, Idempotency และ Data Cleanse, และระบบแจ้งเตือนอัตโนมัติ ซึ่งผมจะอธิบายทีละส่วนครับ</a:t>
             </a:r>
             <a:endParaRPr lang="en-US" dirty="0"/>
           </a:p>
@@ -2265,7 +2265,7 @@
           <a:p>
             <a:r>
               <a:rPr lang="en-US" dirty="0"/>
-              <a:t/>
+              <a:t>ตรงนี้คือส่วนสำคัญที่สุดของ Task 2 ครับ ปกติถ้าโปรแกรมต้อง 'รอ' อะไรบางอย่าง เช่นรอไฟล์ใหม่ วิธีเดิมคือ mode แบบ poke ซึ่งจะครอบครอง worker slot ไว้ตลอดเวลาที่รอ เหมือนคนจองที่นั่งไว้เฉยๆ ทั้งที่ยังไม่ถึงคิว ส่วน mode reschedule จะดีขึ้นมาหน่อยคือคืน slot บางช่วง แต่ที่ผมเลือกใช้คือ Deferrable Operator ซึ่งจะคืน worker slot ทั้งหมดระหว่างรอ ให้ตัว Triggerer เป็นคนจัดการแทน ผมทดสอบจริงแล้วเห็นว่า state ของ task เปลี่ยนเป็น deferred ตรงตามที่ออกแบบไว้ทุกกรณีครับ</a:t>
             </a:r>
             <a:endParaRPr lang="en-US" dirty="0"/>
           </a:p>
@@ -2353,7 +2353,7 @@
           <a:p>
             <a:r>
               <a:rPr lang="en-US" dirty="0"/>
-              <a:t/>
+              <a:t>อีกจุดที่โจทย์เน้นมากคือ Idempotency หรือการรันซ้ำแล้วข้อมูลไม่ซ้ำซ้อน ผมใช้คำสั่ง SQL แบบ ON CONFLICT DO UPDATE ตามที่เห็นในโค้ดนี้ครับ และผมทดสอบจริงโดยเอาไฟล์เดิมมา process ซ้ำสองรอบ ผลคือจำนวนแถวในฐานข้อมูลยังคงเป็น 58 แถวเท่าเดิม ไม่เพิ่มขึ้นเลย และสำหรับข้อมูลที่ผิดปกติ ผมไม่ได้ทิ้งทันทีนะครับ แต่จะ flag ไว้ให้ตรวจสอบภายหลังแทน เพื่อรักษาความถูกต้องของฐานข้อมูล</a:t>
             </a:r>
             <a:endParaRPr lang="en-US" dirty="0"/>
           </a:p>
@@ -2441,7 +2441,7 @@
           <a:p>
             <a:r>
               <a:rPr lang="en-US" dirty="0"/>
-              <a:t/>
+              <a:t>สุดท้ายของ Task 2 คือระบบแจ้งเตือนอัตโนมัติครับ เมื่อ pipeline ประมวลผลเสร็จแล้วพบว่ามีความผิดปกติ ระบบจะประกอบข้อความแล้วส่งผ่าน Telegram Bot หรือ Slack Webhook โดยอัตโนมัติ ตอนนี้ผมยังไม่ได้ผูก token จริง เลยรันเป็นโหมด dry-run ที่บันทึก log ข้อความไว้แทน แต่ logic ทั้งหมดพร้อมใช้งานจริงทันทีที่ใส่ token เข้าไปครับ</a:t>
             </a:r>
             <a:endParaRPr lang="en-US" dirty="0"/>
           </a:p>
@@ -3047,7 +3047,7 @@
       </p:grpSpPr>
       <p:sp>
         <p:nvSpPr>
-          <p:cNvPr id="2" name="Shape 0"/>
+          <p:cNvPr id="3" name="Shape 0"/>
           <p:cNvSpPr/>
           <p:nvPr/>
         </p:nvSpPr>
@@ -3067,7 +3067,7 @@
       </p:sp>
       <p:sp>
         <p:nvSpPr>
-          <p:cNvPr id="3" name="Shape 1"/>
+          <p:cNvPr id="4" name="Shape 1"/>
           <p:cNvSpPr/>
           <p:nvPr/>
         </p:nvSpPr>
@@ -3087,7 +3087,7 @@
       </p:sp>
       <p:sp>
         <p:nvSpPr>
-          <p:cNvPr id="4" name="Text 2"/>
+          <p:cNvPr id="5" name="Text 2"/>
           <p:cNvSpPr txBox="1"/>
           <p:nvPr/>
         </p:nvSpPr>
@@ -3126,7 +3126,7 @@
       </p:sp>
       <p:sp>
         <p:nvSpPr>
-          <p:cNvPr id="5" name="Text 3"/>
+          <p:cNvPr id="6" name="Text 3"/>
           <p:cNvSpPr txBox="1"/>
           <p:nvPr/>
         </p:nvSpPr>
@@ -3188,7 +3188,7 @@
       </p:sp>
       <p:sp>
         <p:nvSpPr>
-          <p:cNvPr id="6" name="Text 4"/>
+          <p:cNvPr id="7" name="Text 4"/>
           <p:cNvSpPr txBox="1"/>
           <p:nvPr/>
         </p:nvSpPr>
@@ -3227,7 +3227,7 @@
       </p:sp>
       <p:sp>
         <p:nvSpPr>
-          <p:cNvPr id="7" name="Shape 5"/>
+          <p:cNvPr id="8" name="Shape 5"/>
           <p:cNvSpPr/>
           <p:nvPr/>
         </p:nvSpPr>
@@ -3247,7 +3247,7 @@
       </p:sp>
       <p:sp>
         <p:nvSpPr>
-          <p:cNvPr id="8" name="Text 6"/>
+          <p:cNvPr id="9" name="Text 6"/>
           <p:cNvSpPr txBox="1"/>
           <p:nvPr/>
         </p:nvSpPr>
@@ -3393,7 +3393,7 @@
       </p:grpSpPr>
       <p:sp>
         <p:nvSpPr>
-          <p:cNvPr id="2" name="Text 0"/>
+          <p:cNvPr id="3" name="Text 0"/>
           <p:cNvSpPr txBox="1"/>
           <p:nvPr/>
         </p:nvSpPr>
@@ -3432,7 +3432,7 @@
       </p:sp>
       <p:sp>
         <p:nvSpPr>
-          <p:cNvPr id="3" name="Text 1"/>
+          <p:cNvPr id="4" name="Text 1"/>
           <p:cNvSpPr txBox="1"/>
           <p:nvPr/>
         </p:nvSpPr>
@@ -3471,7 +3471,7 @@
       </p:sp>
       <p:graphicFrame>
         <p:nvGraphicFramePr>
-          <p:cNvPr id="4" name="Chart 0" descr=""/>
+          <p:cNvPr id="5" name="Chart 0" descr=""/>
           <p:cNvGraphicFramePr/>
           <p:nvPr/>
         </p:nvGraphicFramePr>
@@ -3487,7 +3487,7 @@
       </p:graphicFrame>
       <p:sp>
         <p:nvSpPr>
-          <p:cNvPr id="5" name="Text 2"/>
+          <p:cNvPr id="6" name="Text 2"/>
           <p:cNvSpPr txBox="1"/>
           <p:nvPr/>
         </p:nvSpPr>
@@ -3526,7 +3526,7 @@
       </p:sp>
       <p:sp>
         <p:nvSpPr>
-          <p:cNvPr id="6" name="Shape 3"/>
+          <p:cNvPr id="7" name="Shape 3"/>
           <p:cNvSpPr/>
           <p:nvPr/>
         </p:nvSpPr>
@@ -3548,7 +3548,7 @@
       </p:sp>
       <p:sp>
         <p:nvSpPr>
-          <p:cNvPr id="7" name="Text 4"/>
+          <p:cNvPr id="8" name="Text 4"/>
           <p:cNvSpPr txBox="1"/>
           <p:nvPr/>
         </p:nvSpPr>
@@ -3587,7 +3587,7 @@
       </p:sp>
       <p:sp>
         <p:nvSpPr>
-          <p:cNvPr id="8" name="Text 5"/>
+          <p:cNvPr id="9" name="Text 5"/>
           <p:cNvSpPr txBox="1"/>
           <p:nvPr/>
         </p:nvSpPr>
@@ -3626,7 +3626,7 @@
       </p:sp>
       <p:sp>
         <p:nvSpPr>
-          <p:cNvPr id="9" name="Shape 6"/>
+          <p:cNvPr id="10" name="Shape 6"/>
           <p:cNvSpPr/>
           <p:nvPr/>
         </p:nvSpPr>
@@ -3648,7 +3648,7 @@
       </p:sp>
       <p:sp>
         <p:nvSpPr>
-          <p:cNvPr id="10" name="Text 7"/>
+          <p:cNvPr id="11" name="Text 7"/>
           <p:cNvSpPr txBox="1"/>
           <p:nvPr/>
         </p:nvSpPr>
@@ -3687,7 +3687,7 @@
       </p:sp>
       <p:sp>
         <p:nvSpPr>
-          <p:cNvPr id="11" name="Text 8"/>
+          <p:cNvPr id="12" name="Text 8"/>
           <p:cNvSpPr txBox="1"/>
           <p:nvPr/>
         </p:nvSpPr>
@@ -3726,7 +3726,7 @@
       </p:sp>
       <p:sp>
         <p:nvSpPr>
-          <p:cNvPr id="12" name="Shape 9"/>
+          <p:cNvPr id="13" name="Shape 9"/>
           <p:cNvSpPr/>
           <p:nvPr/>
         </p:nvSpPr>
@@ -3748,7 +3748,7 @@
       </p:sp>
       <p:sp>
         <p:nvSpPr>
-          <p:cNvPr id="13" name="Text 10"/>
+          <p:cNvPr id="14" name="Text 10"/>
           <p:cNvSpPr txBox="1"/>
           <p:nvPr/>
         </p:nvSpPr>
@@ -3787,7 +3787,7 @@
       </p:sp>
       <p:sp>
         <p:nvSpPr>
-          <p:cNvPr id="14" name="Text 11"/>
+          <p:cNvPr id="15" name="Text 11"/>
           <p:cNvSpPr txBox="1"/>
           <p:nvPr/>
         </p:nvSpPr>
@@ -3899,7 +3899,7 @@
       </p:grpSpPr>
       <p:sp>
         <p:nvSpPr>
-          <p:cNvPr id="2" name="Text 0"/>
+          <p:cNvPr id="3" name="Text 0"/>
           <p:cNvSpPr txBox="1"/>
           <p:nvPr/>
         </p:nvSpPr>
@@ -3938,7 +3938,7 @@
       </p:sp>
       <p:sp>
         <p:nvSpPr>
-          <p:cNvPr id="3" name="Text 1"/>
+          <p:cNvPr id="4" name="Text 1"/>
           <p:cNvSpPr txBox="1"/>
           <p:nvPr/>
         </p:nvSpPr>
@@ -3977,7 +3977,7 @@
       </p:sp>
       <p:sp>
         <p:nvSpPr>
-          <p:cNvPr id="4" name="Shape 2"/>
+          <p:cNvPr id="5" name="Shape 2"/>
           <p:cNvSpPr/>
           <p:nvPr/>
         </p:nvSpPr>
@@ -3999,7 +3999,7 @@
       </p:sp>
       <p:sp>
         <p:nvSpPr>
-          <p:cNvPr id="5" name="Shape 3"/>
+          <p:cNvPr id="6" name="Shape 3"/>
           <p:cNvSpPr/>
           <p:nvPr/>
         </p:nvSpPr>
@@ -4019,7 +4019,7 @@
       </p:sp>
       <p:sp>
         <p:nvSpPr>
-          <p:cNvPr id="6" name="Text 4"/>
+          <p:cNvPr id="7" name="Text 4"/>
           <p:cNvSpPr txBox="1"/>
           <p:nvPr/>
         </p:nvSpPr>
@@ -4058,7 +4058,7 @@
       </p:sp>
       <p:sp>
         <p:nvSpPr>
-          <p:cNvPr id="7" name="Text 5"/>
+          <p:cNvPr id="8" name="Text 5"/>
           <p:cNvSpPr txBox="1"/>
           <p:nvPr/>
         </p:nvSpPr>
@@ -4097,7 +4097,7 @@
       </p:sp>
       <p:sp>
         <p:nvSpPr>
-          <p:cNvPr id="8" name="Text 6"/>
+          <p:cNvPr id="9" name="Text 6"/>
           <p:cNvSpPr txBox="1"/>
           <p:nvPr/>
         </p:nvSpPr>
@@ -4136,7 +4136,7 @@
       </p:sp>
       <p:sp>
         <p:nvSpPr>
-          <p:cNvPr id="9" name="Text 7"/>
+          <p:cNvPr id="10" name="Text 7"/>
           <p:cNvSpPr txBox="1"/>
           <p:nvPr/>
         </p:nvSpPr>
@@ -4175,7 +4175,7 @@
       </p:sp>
       <p:sp>
         <p:nvSpPr>
-          <p:cNvPr id="10" name="Shape 8"/>
+          <p:cNvPr id="11" name="Shape 8"/>
           <p:cNvSpPr/>
           <p:nvPr/>
         </p:nvSpPr>
@@ -4197,7 +4197,7 @@
       </p:sp>
       <p:sp>
         <p:nvSpPr>
-          <p:cNvPr id="11" name="Shape 9"/>
+          <p:cNvPr id="12" name="Shape 9"/>
           <p:cNvSpPr/>
           <p:nvPr/>
         </p:nvSpPr>
@@ -4217,7 +4217,7 @@
       </p:sp>
       <p:sp>
         <p:nvSpPr>
-          <p:cNvPr id="12" name="Text 10"/>
+          <p:cNvPr id="13" name="Text 10"/>
           <p:cNvSpPr txBox="1"/>
           <p:nvPr/>
         </p:nvSpPr>
@@ -4256,7 +4256,7 @@
       </p:sp>
       <p:sp>
         <p:nvSpPr>
-          <p:cNvPr id="13" name="Text 11"/>
+          <p:cNvPr id="14" name="Text 11"/>
           <p:cNvSpPr txBox="1"/>
           <p:nvPr/>
         </p:nvSpPr>
@@ -4295,7 +4295,7 @@
       </p:sp>
       <p:sp>
         <p:nvSpPr>
-          <p:cNvPr id="14" name="Text 12"/>
+          <p:cNvPr id="15" name="Text 12"/>
           <p:cNvSpPr txBox="1"/>
           <p:nvPr/>
         </p:nvSpPr>
@@ -4334,7 +4334,7 @@
       </p:sp>
       <p:sp>
         <p:nvSpPr>
-          <p:cNvPr id="15" name="Text 13"/>
+          <p:cNvPr id="16" name="Text 13"/>
           <p:cNvSpPr txBox="1"/>
           <p:nvPr/>
         </p:nvSpPr>
@@ -4373,7 +4373,7 @@
       </p:sp>
       <p:sp>
         <p:nvSpPr>
-          <p:cNvPr id="16" name="Shape 14"/>
+          <p:cNvPr id="17" name="Shape 14"/>
           <p:cNvSpPr/>
           <p:nvPr/>
         </p:nvSpPr>
@@ -4395,7 +4395,7 @@
       </p:sp>
       <p:sp>
         <p:nvSpPr>
-          <p:cNvPr id="17" name="Shape 15"/>
+          <p:cNvPr id="18" name="Shape 15"/>
           <p:cNvSpPr/>
           <p:nvPr/>
         </p:nvSpPr>
@@ -4415,7 +4415,7 @@
       </p:sp>
       <p:sp>
         <p:nvSpPr>
-          <p:cNvPr id="18" name="Text 16"/>
+          <p:cNvPr id="19" name="Text 16"/>
           <p:cNvSpPr txBox="1"/>
           <p:nvPr/>
         </p:nvSpPr>
@@ -4454,7 +4454,7 @@
       </p:sp>
       <p:sp>
         <p:nvSpPr>
-          <p:cNvPr id="19" name="Text 17"/>
+          <p:cNvPr id="20" name="Text 17"/>
           <p:cNvSpPr txBox="1"/>
           <p:nvPr/>
         </p:nvSpPr>
@@ -4493,7 +4493,7 @@
       </p:sp>
       <p:sp>
         <p:nvSpPr>
-          <p:cNvPr id="20" name="Text 18"/>
+          <p:cNvPr id="21" name="Text 18"/>
           <p:cNvSpPr txBox="1"/>
           <p:nvPr/>
         </p:nvSpPr>
@@ -4532,7 +4532,7 @@
       </p:sp>
       <p:sp>
         <p:nvSpPr>
-          <p:cNvPr id="21" name="Text 19"/>
+          <p:cNvPr id="22" name="Text 19"/>
           <p:cNvSpPr txBox="1"/>
           <p:nvPr/>
         </p:nvSpPr>
@@ -4571,7 +4571,7 @@
       </p:sp>
       <p:sp>
         <p:nvSpPr>
-          <p:cNvPr id="22" name="Shape 20"/>
+          <p:cNvPr id="23" name="Shape 20"/>
           <p:cNvSpPr/>
           <p:nvPr/>
         </p:nvSpPr>
@@ -4593,7 +4593,7 @@
       </p:sp>
       <p:sp>
         <p:nvSpPr>
-          <p:cNvPr id="23" name="Text 21"/>
+          <p:cNvPr id="24" name="Text 21"/>
           <p:cNvSpPr txBox="1"/>
           <p:nvPr/>
         </p:nvSpPr>
@@ -4632,7 +4632,7 @@
       </p:sp>
       <p:sp>
         <p:nvSpPr>
-          <p:cNvPr id="24" name="Text 22"/>
+          <p:cNvPr id="25" name="Text 22"/>
           <p:cNvSpPr txBox="1"/>
           <p:nvPr/>
         </p:nvSpPr>
@@ -4671,7 +4671,7 @@
       </p:sp>
       <p:sp>
         <p:nvSpPr>
-          <p:cNvPr id="25" name="Text 23"/>
+          <p:cNvPr id="26" name="Text 23"/>
           <p:cNvSpPr txBox="1"/>
           <p:nvPr/>
         </p:nvSpPr>
@@ -4783,7 +4783,7 @@
       </p:grpSpPr>
       <p:sp>
         <p:nvSpPr>
-          <p:cNvPr id="2" name="Text 0"/>
+          <p:cNvPr id="3" name="Text 0"/>
           <p:cNvSpPr txBox="1"/>
           <p:nvPr/>
         </p:nvSpPr>
@@ -4822,7 +4822,7 @@
       </p:sp>
       <p:sp>
         <p:nvSpPr>
-          <p:cNvPr id="3" name="Text 1"/>
+          <p:cNvPr id="4" name="Text 1"/>
           <p:cNvSpPr txBox="1"/>
           <p:nvPr/>
         </p:nvSpPr>
@@ -4861,7 +4861,7 @@
       </p:sp>
       <p:sp>
         <p:nvSpPr>
-          <p:cNvPr id="4" name="Text 2"/>
+          <p:cNvPr id="5" name="Text 2"/>
           <p:cNvSpPr txBox="1"/>
           <p:nvPr/>
         </p:nvSpPr>
@@ -4900,7 +4900,7 @@
       </p:sp>
       <p:sp>
         <p:nvSpPr>
-          <p:cNvPr id="5" name="Shape 3"/>
+          <p:cNvPr id="6" name="Shape 3"/>
           <p:cNvSpPr/>
           <p:nvPr/>
         </p:nvSpPr>
@@ -4920,7 +4920,7 @@
       </p:sp>
       <p:sp>
         <p:nvSpPr>
-          <p:cNvPr id="6" name="Text 4"/>
+          <p:cNvPr id="7" name="Text 4"/>
           <p:cNvSpPr txBox="1"/>
           <p:nvPr/>
         </p:nvSpPr>
@@ -4959,7 +4959,7 @@
       </p:sp>
       <p:sp>
         <p:nvSpPr>
-          <p:cNvPr id="7" name="Text 5"/>
+          <p:cNvPr id="8" name="Text 5"/>
           <p:cNvSpPr txBox="1"/>
           <p:nvPr/>
         </p:nvSpPr>
@@ -4998,7 +4998,7 @@
       </p:sp>
       <p:sp>
         <p:nvSpPr>
-          <p:cNvPr id="8" name="Shape 6"/>
+          <p:cNvPr id="9" name="Shape 6"/>
           <p:cNvSpPr/>
           <p:nvPr/>
         </p:nvSpPr>
@@ -5018,7 +5018,7 @@
       </p:sp>
       <p:sp>
         <p:nvSpPr>
-          <p:cNvPr id="9" name="Text 7"/>
+          <p:cNvPr id="10" name="Text 7"/>
           <p:cNvSpPr txBox="1"/>
           <p:nvPr/>
         </p:nvSpPr>
@@ -5057,7 +5057,7 @@
       </p:sp>
       <p:sp>
         <p:nvSpPr>
-          <p:cNvPr id="10" name="Text 8"/>
+          <p:cNvPr id="11" name="Text 8"/>
           <p:cNvSpPr txBox="1"/>
           <p:nvPr/>
         </p:nvSpPr>
@@ -5096,7 +5096,7 @@
       </p:sp>
       <p:sp>
         <p:nvSpPr>
-          <p:cNvPr id="11" name="Shape 9"/>
+          <p:cNvPr id="12" name="Shape 9"/>
           <p:cNvSpPr/>
           <p:nvPr/>
         </p:nvSpPr>
@@ -5116,7 +5116,7 @@
       </p:sp>
       <p:sp>
         <p:nvSpPr>
-          <p:cNvPr id="12" name="Text 10"/>
+          <p:cNvPr id="13" name="Text 10"/>
           <p:cNvSpPr txBox="1"/>
           <p:nvPr/>
         </p:nvSpPr>
@@ -5155,7 +5155,7 @@
       </p:sp>
       <p:sp>
         <p:nvSpPr>
-          <p:cNvPr id="13" name="Text 11"/>
+          <p:cNvPr id="14" name="Text 11"/>
           <p:cNvSpPr txBox="1"/>
           <p:nvPr/>
         </p:nvSpPr>
@@ -5194,7 +5194,7 @@
       </p:sp>
       <p:sp>
         <p:nvSpPr>
-          <p:cNvPr id="14" name="Shape 12"/>
+          <p:cNvPr id="15" name="Shape 12"/>
           <p:cNvSpPr/>
           <p:nvPr/>
         </p:nvSpPr>
@@ -5214,7 +5214,7 @@
       </p:sp>
       <p:sp>
         <p:nvSpPr>
-          <p:cNvPr id="15" name="Text 13"/>
+          <p:cNvPr id="16" name="Text 13"/>
           <p:cNvSpPr txBox="1"/>
           <p:nvPr/>
         </p:nvSpPr>
@@ -5253,7 +5253,7 @@
       </p:sp>
       <p:sp>
         <p:nvSpPr>
-          <p:cNvPr id="16" name="Text 14"/>
+          <p:cNvPr id="17" name="Text 14"/>
           <p:cNvSpPr txBox="1"/>
           <p:nvPr/>
         </p:nvSpPr>
@@ -5292,7 +5292,7 @@
       </p:sp>
       <p:sp>
         <p:nvSpPr>
-          <p:cNvPr id="17" name="Shape 15"/>
+          <p:cNvPr id="18" name="Shape 15"/>
           <p:cNvSpPr/>
           <p:nvPr/>
         </p:nvSpPr>
@@ -5314,7 +5314,7 @@
       </p:sp>
       <p:sp>
         <p:nvSpPr>
-          <p:cNvPr id="18" name="Text 16"/>
+          <p:cNvPr id="19" name="Text 16"/>
           <p:cNvSpPr txBox="1"/>
           <p:nvPr/>
         </p:nvSpPr>
@@ -5426,7 +5426,7 @@
       </p:grpSpPr>
       <p:sp>
         <p:nvSpPr>
-          <p:cNvPr id="2" name="Text 0"/>
+          <p:cNvPr id="3" name="Text 0"/>
           <p:cNvSpPr txBox="1"/>
           <p:nvPr/>
         </p:nvSpPr>
@@ -5465,7 +5465,7 @@
       </p:sp>
       <p:sp>
         <p:nvSpPr>
-          <p:cNvPr id="3" name="Text 1"/>
+          <p:cNvPr id="4" name="Text 1"/>
           <p:cNvSpPr txBox="1"/>
           <p:nvPr/>
         </p:nvSpPr>
@@ -6947,7 +6947,7 @@
       </p:graphicFrame>
       <p:sp>
         <p:nvSpPr>
-          <p:cNvPr id="5" name="Text 2"/>
+          <p:cNvPr id="6" name="Text 2"/>
           <p:cNvSpPr txBox="1"/>
           <p:nvPr/>
         </p:nvSpPr>
@@ -6986,7 +6986,7 @@
       </p:sp>
       <p:sp>
         <p:nvSpPr>
-          <p:cNvPr id="6" name="Shape 3"/>
+          <p:cNvPr id="7" name="Shape 3"/>
           <p:cNvSpPr/>
           <p:nvPr/>
         </p:nvSpPr>
@@ -7008,7 +7008,7 @@
       </p:sp>
       <p:sp>
         <p:nvSpPr>
-          <p:cNvPr id="7" name="Text 4"/>
+          <p:cNvPr id="8" name="Text 4"/>
           <p:cNvSpPr txBox="1"/>
           <p:nvPr/>
         </p:nvSpPr>
@@ -7120,7 +7120,7 @@
       </p:grpSpPr>
       <p:sp>
         <p:nvSpPr>
-          <p:cNvPr id="2" name="Text 0"/>
+          <p:cNvPr id="3" name="Text 0"/>
           <p:cNvSpPr txBox="1"/>
           <p:nvPr/>
         </p:nvSpPr>
@@ -7159,7 +7159,7 @@
       </p:sp>
       <p:sp>
         <p:nvSpPr>
-          <p:cNvPr id="3" name="Text 1"/>
+          <p:cNvPr id="4" name="Text 1"/>
           <p:cNvSpPr txBox="1"/>
           <p:nvPr/>
         </p:nvSpPr>
@@ -8671,7 +8671,7 @@
       </p:graphicFrame>
       <p:sp>
         <p:nvSpPr>
-          <p:cNvPr id="5" name="Text 2"/>
+          <p:cNvPr id="6" name="Text 2"/>
           <p:cNvSpPr txBox="1"/>
           <p:nvPr/>
         </p:nvSpPr>
@@ -8783,7 +8783,7 @@
       </p:grpSpPr>
       <p:sp>
         <p:nvSpPr>
-          <p:cNvPr id="2" name="Text 0"/>
+          <p:cNvPr id="3" name="Text 0"/>
           <p:cNvSpPr txBox="1"/>
           <p:nvPr/>
         </p:nvSpPr>
@@ -8822,7 +8822,7 @@
       </p:sp>
       <p:sp>
         <p:nvSpPr>
-          <p:cNvPr id="3" name="Text 1"/>
+          <p:cNvPr id="4" name="Text 1"/>
           <p:cNvSpPr txBox="1"/>
           <p:nvPr/>
         </p:nvSpPr>
@@ -8861,7 +8861,7 @@
       </p:sp>
       <p:sp>
         <p:nvSpPr>
-          <p:cNvPr id="4" name="Shape 2"/>
+          <p:cNvPr id="5" name="Shape 2"/>
           <p:cNvSpPr/>
           <p:nvPr/>
         </p:nvSpPr>
@@ -8883,7 +8883,7 @@
       </p:sp>
       <p:sp>
         <p:nvSpPr>
-          <p:cNvPr id="5" name="Shape 3"/>
+          <p:cNvPr id="6" name="Shape 3"/>
           <p:cNvSpPr/>
           <p:nvPr/>
         </p:nvSpPr>
@@ -8905,7 +8905,7 @@
       </p:sp>
       <p:sp>
         <p:nvSpPr>
-          <p:cNvPr id="6" name="Text 4"/>
+          <p:cNvPr id="7" name="Text 4"/>
           <p:cNvSpPr txBox="1"/>
           <p:nvPr/>
         </p:nvSpPr>
@@ -8944,7 +8944,7 @@
       </p:sp>
       <p:sp>
         <p:nvSpPr>
-          <p:cNvPr id="7" name="Text 5"/>
+          <p:cNvPr id="8" name="Text 5"/>
           <p:cNvSpPr txBox="1"/>
           <p:nvPr/>
         </p:nvSpPr>
@@ -8983,7 +8983,7 @@
       </p:sp>
       <p:sp>
         <p:nvSpPr>
-          <p:cNvPr id="8" name="Text 6"/>
+          <p:cNvPr id="9" name="Text 6"/>
           <p:cNvSpPr txBox="1"/>
           <p:nvPr/>
         </p:nvSpPr>
@@ -9022,7 +9022,7 @@
       </p:sp>
       <p:sp>
         <p:nvSpPr>
-          <p:cNvPr id="9" name="Shape 7"/>
+          <p:cNvPr id="10" name="Shape 7"/>
           <p:cNvSpPr/>
           <p:nvPr/>
         </p:nvSpPr>
@@ -9044,7 +9044,7 @@
       </p:sp>
       <p:sp>
         <p:nvSpPr>
-          <p:cNvPr id="10" name="Shape 8"/>
+          <p:cNvPr id="11" name="Shape 8"/>
           <p:cNvSpPr/>
           <p:nvPr/>
         </p:nvSpPr>
@@ -9066,7 +9066,7 @@
       </p:sp>
       <p:sp>
         <p:nvSpPr>
-          <p:cNvPr id="11" name="Text 9"/>
+          <p:cNvPr id="12" name="Text 9"/>
           <p:cNvSpPr txBox="1"/>
           <p:nvPr/>
         </p:nvSpPr>
@@ -9105,7 +9105,7 @@
       </p:sp>
       <p:sp>
         <p:nvSpPr>
-          <p:cNvPr id="12" name="Text 10"/>
+          <p:cNvPr id="13" name="Text 10"/>
           <p:cNvSpPr txBox="1"/>
           <p:nvPr/>
         </p:nvSpPr>
@@ -9144,7 +9144,7 @@
       </p:sp>
       <p:sp>
         <p:nvSpPr>
-          <p:cNvPr id="13" name="Text 11"/>
+          <p:cNvPr id="14" name="Text 11"/>
           <p:cNvSpPr txBox="1"/>
           <p:nvPr/>
         </p:nvSpPr>
@@ -9183,7 +9183,7 @@
       </p:sp>
       <p:sp>
         <p:nvSpPr>
-          <p:cNvPr id="14" name="Shape 12"/>
+          <p:cNvPr id="15" name="Shape 12"/>
           <p:cNvSpPr/>
           <p:nvPr/>
         </p:nvSpPr>
@@ -9205,7 +9205,7 @@
       </p:sp>
       <p:sp>
         <p:nvSpPr>
-          <p:cNvPr id="15" name="Shape 13"/>
+          <p:cNvPr id="16" name="Shape 13"/>
           <p:cNvSpPr/>
           <p:nvPr/>
         </p:nvSpPr>
@@ -9227,7 +9227,7 @@
       </p:sp>
       <p:sp>
         <p:nvSpPr>
-          <p:cNvPr id="16" name="Text 14"/>
+          <p:cNvPr id="17" name="Text 14"/>
           <p:cNvSpPr txBox="1"/>
           <p:nvPr/>
         </p:nvSpPr>
@@ -9266,7 +9266,7 @@
       </p:sp>
       <p:sp>
         <p:nvSpPr>
-          <p:cNvPr id="17" name="Text 15"/>
+          <p:cNvPr id="18" name="Text 15"/>
           <p:cNvSpPr txBox="1"/>
           <p:nvPr/>
         </p:nvSpPr>
@@ -9305,7 +9305,7 @@
       </p:sp>
       <p:sp>
         <p:nvSpPr>
-          <p:cNvPr id="18" name="Text 16"/>
+          <p:cNvPr id="19" name="Text 16"/>
           <p:cNvSpPr txBox="1"/>
           <p:nvPr/>
         </p:nvSpPr>
@@ -9344,7 +9344,7 @@
       </p:sp>
       <p:sp>
         <p:nvSpPr>
-          <p:cNvPr id="19" name="Shape 17"/>
+          <p:cNvPr id="20" name="Shape 17"/>
           <p:cNvSpPr/>
           <p:nvPr/>
         </p:nvSpPr>
@@ -9366,7 +9366,7 @@
       </p:sp>
       <p:sp>
         <p:nvSpPr>
-          <p:cNvPr id="20" name="Shape 18"/>
+          <p:cNvPr id="21" name="Shape 18"/>
           <p:cNvSpPr/>
           <p:nvPr/>
         </p:nvSpPr>
@@ -9388,7 +9388,7 @@
       </p:sp>
       <p:sp>
         <p:nvSpPr>
-          <p:cNvPr id="21" name="Text 19"/>
+          <p:cNvPr id="22" name="Text 19"/>
           <p:cNvSpPr txBox="1"/>
           <p:nvPr/>
         </p:nvSpPr>
@@ -9427,7 +9427,7 @@
       </p:sp>
       <p:sp>
         <p:nvSpPr>
-          <p:cNvPr id="22" name="Text 20"/>
+          <p:cNvPr id="23" name="Text 20"/>
           <p:cNvSpPr txBox="1"/>
           <p:nvPr/>
         </p:nvSpPr>
@@ -9466,7 +9466,7 @@
       </p:sp>
       <p:sp>
         <p:nvSpPr>
-          <p:cNvPr id="23" name="Text 21"/>
+          <p:cNvPr id="24" name="Text 21"/>
           <p:cNvSpPr txBox="1"/>
           <p:nvPr/>
         </p:nvSpPr>
@@ -9578,7 +9578,7 @@
       </p:grpSpPr>
       <p:sp>
         <p:nvSpPr>
-          <p:cNvPr id="2" name="Shape 0"/>
+          <p:cNvPr id="3" name="Shape 0"/>
           <p:cNvSpPr/>
           <p:nvPr/>
         </p:nvSpPr>
@@ -9598,7 +9598,7 @@
       </p:sp>
       <p:sp>
         <p:nvSpPr>
-          <p:cNvPr id="3" name="Shape 1"/>
+          <p:cNvPr id="4" name="Shape 1"/>
           <p:cNvSpPr/>
           <p:nvPr/>
         </p:nvSpPr>
@@ -9618,7 +9618,7 @@
       </p:sp>
       <p:sp>
         <p:nvSpPr>
-          <p:cNvPr id="4" name="Text 2"/>
+          <p:cNvPr id="5" name="Text 2"/>
           <p:cNvSpPr txBox="1"/>
           <p:nvPr/>
         </p:nvSpPr>
@@ -9657,7 +9657,7 @@
       </p:sp>
       <p:sp>
         <p:nvSpPr>
-          <p:cNvPr id="5" name="Text 3"/>
+          <p:cNvPr id="6" name="Text 3"/>
           <p:cNvSpPr txBox="1"/>
           <p:nvPr/>
         </p:nvSpPr>
@@ -9696,7 +9696,7 @@
       </p:sp>
       <p:sp>
         <p:nvSpPr>
-          <p:cNvPr id="6" name="Text 4"/>
+          <p:cNvPr id="7" name="Text 4"/>
           <p:cNvSpPr txBox="1"/>
           <p:nvPr/>
         </p:nvSpPr>
@@ -9825,7 +9825,7 @@
       </p:grpSpPr>
       <p:sp>
         <p:nvSpPr>
-          <p:cNvPr id="2" name="Text 0"/>
+          <p:cNvPr id="3" name="Text 0"/>
           <p:cNvSpPr txBox="1"/>
           <p:nvPr/>
         </p:nvSpPr>
@@ -9864,7 +9864,7 @@
       </p:sp>
       <p:sp>
         <p:nvSpPr>
-          <p:cNvPr id="3" name="Text 1"/>
+          <p:cNvPr id="4" name="Text 1"/>
           <p:cNvSpPr txBox="1"/>
           <p:nvPr/>
         </p:nvSpPr>
@@ -9903,7 +9903,7 @@
       </p:sp>
       <p:sp>
         <p:nvSpPr>
-          <p:cNvPr id="4" name="Shape 2"/>
+          <p:cNvPr id="5" name="Shape 2"/>
           <p:cNvSpPr/>
           <p:nvPr/>
         </p:nvSpPr>
@@ -9925,7 +9925,7 @@
       </p:sp>
       <p:sp>
         <p:nvSpPr>
-          <p:cNvPr id="5" name="Shape 3"/>
+          <p:cNvPr id="6" name="Shape 3"/>
           <p:cNvSpPr/>
           <p:nvPr/>
         </p:nvSpPr>
@@ -9945,7 +9945,7 @@
       </p:sp>
       <p:sp>
         <p:nvSpPr>
-          <p:cNvPr id="6" name="Text 4"/>
+          <p:cNvPr id="7" name="Text 4"/>
           <p:cNvSpPr txBox="1"/>
           <p:nvPr/>
         </p:nvSpPr>
@@ -9984,7 +9984,7 @@
       </p:sp>
       <p:sp>
         <p:nvSpPr>
-          <p:cNvPr id="7" name="Text 5"/>
+          <p:cNvPr id="8" name="Text 5"/>
           <p:cNvSpPr txBox="1"/>
           <p:nvPr/>
         </p:nvSpPr>
@@ -10023,7 +10023,7 @@
       </p:sp>
       <p:sp>
         <p:nvSpPr>
-          <p:cNvPr id="8" name="Text 6"/>
+          <p:cNvPr id="9" name="Text 6"/>
           <p:cNvSpPr txBox="1"/>
           <p:nvPr/>
         </p:nvSpPr>
@@ -10062,7 +10062,7 @@
       </p:sp>
       <p:sp>
         <p:nvSpPr>
-          <p:cNvPr id="9" name="Shape 7"/>
+          <p:cNvPr id="10" name="Shape 7"/>
           <p:cNvSpPr/>
           <p:nvPr/>
         </p:nvSpPr>
@@ -10084,7 +10084,7 @@
       </p:sp>
       <p:sp>
         <p:nvSpPr>
-          <p:cNvPr id="10" name="Shape 8"/>
+          <p:cNvPr id="11" name="Shape 8"/>
           <p:cNvSpPr/>
           <p:nvPr/>
         </p:nvSpPr>
@@ -10104,7 +10104,7 @@
       </p:sp>
       <p:sp>
         <p:nvSpPr>
-          <p:cNvPr id="11" name="Text 9"/>
+          <p:cNvPr id="12" name="Text 9"/>
           <p:cNvSpPr txBox="1"/>
           <p:nvPr/>
         </p:nvSpPr>
@@ -10143,7 +10143,7 @@
       </p:sp>
       <p:sp>
         <p:nvSpPr>
-          <p:cNvPr id="12" name="Text 10"/>
+          <p:cNvPr id="13" name="Text 10"/>
           <p:cNvSpPr txBox="1"/>
           <p:nvPr/>
         </p:nvSpPr>
@@ -10182,7 +10182,7 @@
       </p:sp>
       <p:sp>
         <p:nvSpPr>
-          <p:cNvPr id="13" name="Text 11"/>
+          <p:cNvPr id="14" name="Text 11"/>
           <p:cNvSpPr txBox="1"/>
           <p:nvPr/>
         </p:nvSpPr>
@@ -10221,7 +10221,7 @@
       </p:sp>
       <p:sp>
         <p:nvSpPr>
-          <p:cNvPr id="14" name="Shape 12"/>
+          <p:cNvPr id="15" name="Shape 12"/>
           <p:cNvSpPr/>
           <p:nvPr/>
         </p:nvSpPr>
@@ -10243,7 +10243,7 @@
       </p:sp>
       <p:sp>
         <p:nvSpPr>
-          <p:cNvPr id="15" name="Shape 13"/>
+          <p:cNvPr id="16" name="Shape 13"/>
           <p:cNvSpPr/>
           <p:nvPr/>
         </p:nvSpPr>
@@ -10263,7 +10263,7 @@
       </p:sp>
       <p:sp>
         <p:nvSpPr>
-          <p:cNvPr id="16" name="Text 14"/>
+          <p:cNvPr id="17" name="Text 14"/>
           <p:cNvSpPr txBox="1"/>
           <p:nvPr/>
         </p:nvSpPr>
@@ -10302,7 +10302,7 @@
       </p:sp>
       <p:sp>
         <p:nvSpPr>
-          <p:cNvPr id="17" name="Text 15"/>
+          <p:cNvPr id="18" name="Text 15"/>
           <p:cNvSpPr txBox="1"/>
           <p:nvPr/>
         </p:nvSpPr>
@@ -10341,7 +10341,7 @@
       </p:sp>
       <p:sp>
         <p:nvSpPr>
-          <p:cNvPr id="18" name="Text 16"/>
+          <p:cNvPr id="19" name="Text 16"/>
           <p:cNvSpPr txBox="1"/>
           <p:nvPr/>
         </p:nvSpPr>
@@ -10380,7 +10380,7 @@
       </p:sp>
       <p:sp>
         <p:nvSpPr>
-          <p:cNvPr id="19" name="Shape 17"/>
+          <p:cNvPr id="20" name="Shape 17"/>
           <p:cNvSpPr/>
           <p:nvPr/>
         </p:nvSpPr>
@@ -10402,7 +10402,7 @@
       </p:sp>
       <p:sp>
         <p:nvSpPr>
-          <p:cNvPr id="20" name="Shape 18"/>
+          <p:cNvPr id="21" name="Shape 18"/>
           <p:cNvSpPr/>
           <p:nvPr/>
         </p:nvSpPr>
@@ -10422,7 +10422,7 @@
       </p:sp>
       <p:sp>
         <p:nvSpPr>
-          <p:cNvPr id="21" name="Text 19"/>
+          <p:cNvPr id="22" name="Text 19"/>
           <p:cNvSpPr txBox="1"/>
           <p:nvPr/>
         </p:nvSpPr>
@@ -10461,7 +10461,7 @@
       </p:sp>
       <p:sp>
         <p:nvSpPr>
-          <p:cNvPr id="22" name="Text 20"/>
+          <p:cNvPr id="23" name="Text 20"/>
           <p:cNvSpPr txBox="1"/>
           <p:nvPr/>
         </p:nvSpPr>
@@ -10500,7 +10500,7 @@
       </p:sp>
       <p:sp>
         <p:nvSpPr>
-          <p:cNvPr id="23" name="Text 21"/>
+          <p:cNvPr id="24" name="Text 21"/>
           <p:cNvSpPr txBox="1"/>
           <p:nvPr/>
         </p:nvSpPr>
@@ -10612,7 +10612,7 @@
       </p:grpSpPr>
       <p:sp>
         <p:nvSpPr>
-          <p:cNvPr id="2" name="Text 0"/>
+          <p:cNvPr id="3" name="Text 0"/>
           <p:cNvSpPr txBox="1"/>
           <p:nvPr/>
         </p:nvSpPr>
@@ -10651,7 +10651,7 @@
       </p:sp>
       <p:sp>
         <p:nvSpPr>
-          <p:cNvPr id="3" name="Text 1"/>
+          <p:cNvPr id="4" name="Text 1"/>
           <p:cNvSpPr txBox="1"/>
           <p:nvPr/>
         </p:nvSpPr>
@@ -10690,7 +10690,7 @@
       </p:sp>
       <p:sp>
         <p:nvSpPr>
-          <p:cNvPr id="4" name="Shape 2"/>
+          <p:cNvPr id="5" name="Shape 2"/>
           <p:cNvSpPr/>
           <p:nvPr/>
         </p:nvSpPr>
@@ -10712,7 +10712,7 @@
       </p:sp>
       <p:sp>
         <p:nvSpPr>
-          <p:cNvPr id="5" name="Shape 3"/>
+          <p:cNvPr id="6" name="Shape 3"/>
           <p:cNvSpPr/>
           <p:nvPr/>
         </p:nvSpPr>
@@ -10732,7 +10732,7 @@
       </p:sp>
       <p:sp>
         <p:nvSpPr>
-          <p:cNvPr id="6" name="Text 4"/>
+          <p:cNvPr id="7" name="Text 4"/>
           <p:cNvSpPr txBox="1"/>
           <p:nvPr/>
         </p:nvSpPr>
@@ -10771,7 +10771,7 @@
       </p:sp>
       <p:sp>
         <p:nvSpPr>
-          <p:cNvPr id="7" name="Text 5"/>
+          <p:cNvPr id="8" name="Text 5"/>
           <p:cNvSpPr txBox="1"/>
           <p:nvPr/>
         </p:nvSpPr>
@@ -10827,7 +10827,7 @@
       </p:sp>
       <p:sp>
         <p:nvSpPr>
-          <p:cNvPr id="8" name="Text 6"/>
+          <p:cNvPr id="9" name="Text 6"/>
           <p:cNvSpPr txBox="1"/>
           <p:nvPr/>
         </p:nvSpPr>
@@ -10866,7 +10866,7 @@
       </p:sp>
       <p:sp>
         <p:nvSpPr>
-          <p:cNvPr id="9" name="Text 7"/>
+          <p:cNvPr id="10" name="Text 7"/>
           <p:cNvSpPr txBox="1"/>
           <p:nvPr/>
         </p:nvSpPr>
@@ -10905,7 +10905,7 @@
       </p:sp>
       <p:sp>
         <p:nvSpPr>
-          <p:cNvPr id="10" name="Shape 8"/>
+          <p:cNvPr id="11" name="Shape 8"/>
           <p:cNvSpPr/>
           <p:nvPr/>
         </p:nvSpPr>
@@ -10927,7 +10927,7 @@
       </p:sp>
       <p:sp>
         <p:nvSpPr>
-          <p:cNvPr id="11" name="Shape 9"/>
+          <p:cNvPr id="12" name="Shape 9"/>
           <p:cNvSpPr/>
           <p:nvPr/>
         </p:nvSpPr>
@@ -10947,7 +10947,7 @@
       </p:sp>
       <p:sp>
         <p:nvSpPr>
-          <p:cNvPr id="12" name="Text 10"/>
+          <p:cNvPr id="13" name="Text 10"/>
           <p:cNvSpPr txBox="1"/>
           <p:nvPr/>
         </p:nvSpPr>
@@ -10986,7 +10986,7 @@
       </p:sp>
       <p:sp>
         <p:nvSpPr>
-          <p:cNvPr id="13" name="Text 11"/>
+          <p:cNvPr id="14" name="Text 11"/>
           <p:cNvSpPr txBox="1"/>
           <p:nvPr/>
         </p:nvSpPr>
@@ -11042,7 +11042,7 @@
       </p:sp>
       <p:sp>
         <p:nvSpPr>
-          <p:cNvPr id="14" name="Text 12"/>
+          <p:cNvPr id="15" name="Text 12"/>
           <p:cNvSpPr txBox="1"/>
           <p:nvPr/>
         </p:nvSpPr>
@@ -11081,7 +11081,7 @@
       </p:sp>
       <p:sp>
         <p:nvSpPr>
-          <p:cNvPr id="15" name="Text 13"/>
+          <p:cNvPr id="16" name="Text 13"/>
           <p:cNvSpPr txBox="1"/>
           <p:nvPr/>
         </p:nvSpPr>
@@ -11120,7 +11120,7 @@
       </p:sp>
       <p:sp>
         <p:nvSpPr>
-          <p:cNvPr id="16" name="Shape 14"/>
+          <p:cNvPr id="17" name="Shape 14"/>
           <p:cNvSpPr/>
           <p:nvPr/>
         </p:nvSpPr>
@@ -11142,7 +11142,7 @@
       </p:sp>
       <p:sp>
         <p:nvSpPr>
-          <p:cNvPr id="17" name="Shape 15"/>
+          <p:cNvPr id="18" name="Shape 15"/>
           <p:cNvSpPr/>
           <p:nvPr/>
         </p:nvSpPr>
@@ -11162,7 +11162,7 @@
       </p:sp>
       <p:sp>
         <p:nvSpPr>
-          <p:cNvPr id="18" name="Text 16"/>
+          <p:cNvPr id="19" name="Text 16"/>
           <p:cNvSpPr txBox="1"/>
           <p:nvPr/>
         </p:nvSpPr>
@@ -11201,7 +11201,7 @@
       </p:sp>
       <p:sp>
         <p:nvSpPr>
-          <p:cNvPr id="19" name="Text 17"/>
+          <p:cNvPr id="20" name="Text 17"/>
           <p:cNvSpPr txBox="1"/>
           <p:nvPr/>
         </p:nvSpPr>
@@ -11240,7 +11240,7 @@
       </p:sp>
       <p:sp>
         <p:nvSpPr>
-          <p:cNvPr id="20" name="Text 18"/>
+          <p:cNvPr id="21" name="Text 18"/>
           <p:cNvSpPr txBox="1"/>
           <p:nvPr/>
         </p:nvSpPr>
@@ -11296,7 +11296,7 @@
       </p:sp>
       <p:sp>
         <p:nvSpPr>
-          <p:cNvPr id="21" name="Text 19"/>
+          <p:cNvPr id="22" name="Text 19"/>
           <p:cNvSpPr txBox="1"/>
           <p:nvPr/>
         </p:nvSpPr>
@@ -11335,7 +11335,7 @@
       </p:sp>
       <p:sp>
         <p:nvSpPr>
-          <p:cNvPr id="22" name="Shape 20"/>
+          <p:cNvPr id="23" name="Shape 20"/>
           <p:cNvSpPr/>
           <p:nvPr/>
         </p:nvSpPr>
@@ -11357,7 +11357,7 @@
       </p:sp>
       <p:sp>
         <p:nvSpPr>
-          <p:cNvPr id="23" name="Shape 21"/>
+          <p:cNvPr id="24" name="Shape 21"/>
           <p:cNvSpPr/>
           <p:nvPr/>
         </p:nvSpPr>
@@ -11377,7 +11377,7 @@
       </p:sp>
       <p:sp>
         <p:nvSpPr>
-          <p:cNvPr id="24" name="Text 22"/>
+          <p:cNvPr id="25" name="Text 22"/>
           <p:cNvSpPr txBox="1"/>
           <p:nvPr/>
         </p:nvSpPr>
@@ -11416,7 +11416,7 @@
       </p:sp>
       <p:sp>
         <p:nvSpPr>
-          <p:cNvPr id="25" name="Text 23"/>
+          <p:cNvPr id="26" name="Text 23"/>
           <p:cNvSpPr txBox="1"/>
           <p:nvPr/>
         </p:nvSpPr>
@@ -11455,7 +11455,7 @@
       </p:sp>
       <p:sp>
         <p:nvSpPr>
-          <p:cNvPr id="26" name="Text 24"/>
+          <p:cNvPr id="27" name="Text 24"/>
           <p:cNvSpPr txBox="1"/>
           <p:nvPr/>
         </p:nvSpPr>
@@ -11511,7 +11511,7 @@
       </p:sp>
       <p:sp>
         <p:nvSpPr>
-          <p:cNvPr id="27" name="Text 25"/>
+          <p:cNvPr id="28" name="Text 25"/>
           <p:cNvSpPr txBox="1"/>
           <p:nvPr/>
         </p:nvSpPr>
@@ -11550,7 +11550,7 @@
       </p:sp>
       <p:sp>
         <p:nvSpPr>
-          <p:cNvPr id="28" name="Shape 26"/>
+          <p:cNvPr id="29" name="Shape 26"/>
           <p:cNvSpPr/>
           <p:nvPr/>
         </p:nvSpPr>
@@ -11572,7 +11572,7 @@
       </p:sp>
       <p:sp>
         <p:nvSpPr>
-          <p:cNvPr id="29" name="Shape 27"/>
+          <p:cNvPr id="30" name="Shape 27"/>
           <p:cNvSpPr/>
           <p:nvPr/>
         </p:nvSpPr>
@@ -11592,7 +11592,7 @@
       </p:sp>
       <p:sp>
         <p:nvSpPr>
-          <p:cNvPr id="30" name="Text 28"/>
+          <p:cNvPr id="31" name="Text 28"/>
           <p:cNvSpPr txBox="1"/>
           <p:nvPr/>
         </p:nvSpPr>
@@ -11631,7 +11631,7 @@
       </p:sp>
       <p:sp>
         <p:nvSpPr>
-          <p:cNvPr id="31" name="Text 29"/>
+          <p:cNvPr id="32" name="Text 29"/>
           <p:cNvSpPr txBox="1"/>
           <p:nvPr/>
         </p:nvSpPr>
@@ -11687,7 +11687,7 @@
       </p:sp>
       <p:sp>
         <p:nvSpPr>
-          <p:cNvPr id="32" name="Text 30"/>
+          <p:cNvPr id="33" name="Text 30"/>
           <p:cNvSpPr txBox="1"/>
           <p:nvPr/>
         </p:nvSpPr>
@@ -11743,7 +11743,7 @@
       </p:sp>
       <p:sp>
         <p:nvSpPr>
-          <p:cNvPr id="33" name="Shape 31"/>
+          <p:cNvPr id="34" name="Shape 31"/>
           <p:cNvSpPr/>
           <p:nvPr/>
         </p:nvSpPr>
@@ -11765,7 +11765,7 @@
       </p:sp>
       <p:sp>
         <p:nvSpPr>
-          <p:cNvPr id="34" name="Text 32"/>
+          <p:cNvPr id="35" name="Text 32"/>
           <p:cNvSpPr txBox="1"/>
           <p:nvPr/>
         </p:nvSpPr>
@@ -11804,7 +11804,7 @@
       </p:sp>
       <p:sp>
         <p:nvSpPr>
-          <p:cNvPr id="35" name="Text 33"/>
+          <p:cNvPr id="36" name="Text 33"/>
           <p:cNvSpPr txBox="1"/>
           <p:nvPr/>
         </p:nvSpPr>
@@ -11843,7 +11843,7 @@
       </p:sp>
       <p:sp>
         <p:nvSpPr>
-          <p:cNvPr id="36" name="Text 34"/>
+          <p:cNvPr id="37" name="Text 34"/>
           <p:cNvSpPr txBox="1"/>
           <p:nvPr/>
         </p:nvSpPr>
@@ -11955,7 +11955,7 @@
       </p:grpSpPr>
       <p:sp>
         <p:nvSpPr>
-          <p:cNvPr id="2" name="Text 0"/>
+          <p:cNvPr id="3" name="Text 0"/>
           <p:cNvSpPr txBox="1"/>
           <p:nvPr/>
         </p:nvSpPr>
@@ -11994,7 +11994,7 @@
       </p:sp>
       <p:sp>
         <p:nvSpPr>
-          <p:cNvPr id="3" name="Text 1"/>
+          <p:cNvPr id="4" name="Text 1"/>
           <p:cNvSpPr txBox="1"/>
           <p:nvPr/>
         </p:nvSpPr>
@@ -12033,7 +12033,7 @@
       </p:sp>
       <p:sp>
         <p:nvSpPr>
-          <p:cNvPr id="4" name="Text 2"/>
+          <p:cNvPr id="5" name="Text 2"/>
           <p:cNvSpPr txBox="1"/>
           <p:nvPr/>
         </p:nvSpPr>
@@ -12072,7 +12072,7 @@
       </p:sp>
       <p:sp>
         <p:nvSpPr>
-          <p:cNvPr id="5" name="Shape 3"/>
+          <p:cNvPr id="6" name="Shape 3"/>
           <p:cNvSpPr/>
           <p:nvPr/>
         </p:nvSpPr>
@@ -12094,7 +12094,7 @@
       </p:sp>
       <p:sp>
         <p:nvSpPr>
-          <p:cNvPr id="6" name="Shape 4"/>
+          <p:cNvPr id="7" name="Shape 4"/>
           <p:cNvSpPr/>
           <p:nvPr/>
         </p:nvSpPr>
@@ -12114,7 +12114,7 @@
       </p:sp>
       <p:sp>
         <p:nvSpPr>
-          <p:cNvPr id="7" name="Text 5"/>
+          <p:cNvPr id="8" name="Text 5"/>
           <p:cNvSpPr txBox="1"/>
           <p:nvPr/>
         </p:nvSpPr>
@@ -12153,7 +12153,7 @@
       </p:sp>
       <p:sp>
         <p:nvSpPr>
-          <p:cNvPr id="8" name="Text 6"/>
+          <p:cNvPr id="9" name="Text 6"/>
           <p:cNvSpPr txBox="1"/>
           <p:nvPr/>
         </p:nvSpPr>
@@ -12192,7 +12192,7 @@
       </p:sp>
       <p:sp>
         <p:nvSpPr>
-          <p:cNvPr id="9" name="Text 7"/>
+          <p:cNvPr id="10" name="Text 7"/>
           <p:cNvSpPr txBox="1"/>
           <p:nvPr/>
         </p:nvSpPr>
@@ -12231,7 +12231,7 @@
       </p:sp>
       <p:sp>
         <p:nvSpPr>
-          <p:cNvPr id="10" name="Shape 8"/>
+          <p:cNvPr id="11" name="Shape 8"/>
           <p:cNvSpPr/>
           <p:nvPr/>
         </p:nvSpPr>
@@ -12253,7 +12253,7 @@
       </p:sp>
       <p:sp>
         <p:nvSpPr>
-          <p:cNvPr id="11" name="Shape 9"/>
+          <p:cNvPr id="12" name="Shape 9"/>
           <p:cNvSpPr/>
           <p:nvPr/>
         </p:nvSpPr>
@@ -12273,7 +12273,7 @@
       </p:sp>
       <p:sp>
         <p:nvSpPr>
-          <p:cNvPr id="12" name="Text 10"/>
+          <p:cNvPr id="13" name="Text 10"/>
           <p:cNvSpPr txBox="1"/>
           <p:nvPr/>
         </p:nvSpPr>
@@ -12312,7 +12312,7 @@
       </p:sp>
       <p:sp>
         <p:nvSpPr>
-          <p:cNvPr id="13" name="Text 11"/>
+          <p:cNvPr id="14" name="Text 11"/>
           <p:cNvSpPr txBox="1"/>
           <p:nvPr/>
         </p:nvSpPr>
@@ -12351,7 +12351,7 @@
       </p:sp>
       <p:sp>
         <p:nvSpPr>
-          <p:cNvPr id="14" name="Text 12"/>
+          <p:cNvPr id="15" name="Text 12"/>
           <p:cNvSpPr txBox="1"/>
           <p:nvPr/>
         </p:nvSpPr>
@@ -12390,7 +12390,7 @@
       </p:sp>
       <p:sp>
         <p:nvSpPr>
-          <p:cNvPr id="15" name="Shape 13"/>
+          <p:cNvPr id="16" name="Shape 13"/>
           <p:cNvSpPr/>
           <p:nvPr/>
         </p:nvSpPr>
@@ -12412,7 +12412,7 @@
       </p:sp>
       <p:sp>
         <p:nvSpPr>
-          <p:cNvPr id="16" name="Shape 14"/>
+          <p:cNvPr id="17" name="Shape 14"/>
           <p:cNvSpPr/>
           <p:nvPr/>
         </p:nvSpPr>
@@ -12432,7 +12432,7 @@
       </p:sp>
       <p:sp>
         <p:nvSpPr>
-          <p:cNvPr id="17" name="Text 15"/>
+          <p:cNvPr id="18" name="Text 15"/>
           <p:cNvSpPr txBox="1"/>
           <p:nvPr/>
         </p:nvSpPr>
@@ -12471,7 +12471,7 @@
       </p:sp>
       <p:sp>
         <p:nvSpPr>
-          <p:cNvPr id="18" name="Text 16"/>
+          <p:cNvPr id="19" name="Text 16"/>
           <p:cNvSpPr txBox="1"/>
           <p:nvPr/>
         </p:nvSpPr>
@@ -12510,7 +12510,7 @@
       </p:sp>
       <p:sp>
         <p:nvSpPr>
-          <p:cNvPr id="19" name="Text 17"/>
+          <p:cNvPr id="20" name="Text 17"/>
           <p:cNvSpPr txBox="1"/>
           <p:nvPr/>
         </p:nvSpPr>
@@ -12549,7 +12549,7 @@
       </p:sp>
       <p:sp>
         <p:nvSpPr>
-          <p:cNvPr id="20" name="Shape 18"/>
+          <p:cNvPr id="21" name="Shape 18"/>
           <p:cNvSpPr/>
           <p:nvPr/>
         </p:nvSpPr>
@@ -12571,7 +12571,7 @@
       </p:sp>
       <p:sp>
         <p:nvSpPr>
-          <p:cNvPr id="21" name="Shape 19"/>
+          <p:cNvPr id="22" name="Shape 19"/>
           <p:cNvSpPr/>
           <p:nvPr/>
         </p:nvSpPr>
@@ -12591,7 +12591,7 @@
       </p:sp>
       <p:sp>
         <p:nvSpPr>
-          <p:cNvPr id="22" name="Text 20"/>
+          <p:cNvPr id="23" name="Text 20"/>
           <p:cNvSpPr txBox="1"/>
           <p:nvPr/>
         </p:nvSpPr>
@@ -12630,7 +12630,7 @@
       </p:sp>
       <p:sp>
         <p:nvSpPr>
-          <p:cNvPr id="23" name="Text 21"/>
+          <p:cNvPr id="24" name="Text 21"/>
           <p:cNvSpPr txBox="1"/>
           <p:nvPr/>
         </p:nvSpPr>
@@ -12669,7 +12669,7 @@
       </p:sp>
       <p:sp>
         <p:nvSpPr>
-          <p:cNvPr id="24" name="Text 22"/>
+          <p:cNvPr id="25" name="Text 22"/>
           <p:cNvSpPr txBox="1"/>
           <p:nvPr/>
         </p:nvSpPr>
@@ -12708,7 +12708,7 @@
       </p:sp>
       <p:sp>
         <p:nvSpPr>
-          <p:cNvPr id="25" name="Text 23"/>
+          <p:cNvPr id="26" name="Text 23"/>
           <p:cNvSpPr txBox="1"/>
           <p:nvPr/>
         </p:nvSpPr>
@@ -12820,7 +12820,7 @@
       </p:grpSpPr>
       <p:sp>
         <p:nvSpPr>
-          <p:cNvPr id="2" name="Text 0"/>
+          <p:cNvPr id="3" name="Text 0"/>
           <p:cNvSpPr txBox="1"/>
           <p:nvPr/>
         </p:nvSpPr>
@@ -12859,7 +12859,7 @@
       </p:sp>
       <p:sp>
         <p:nvSpPr>
-          <p:cNvPr id="3" name="Text 1"/>
+          <p:cNvPr id="4" name="Text 1"/>
           <p:cNvSpPr txBox="1"/>
           <p:nvPr/>
         </p:nvSpPr>
@@ -12898,7 +12898,7 @@
       </p:sp>
       <p:graphicFrame>
         <p:nvGraphicFramePr>
-          <p:cNvPr id="4" name="Chart 0" descr=""/>
+          <p:cNvPr id="5" name="Chart 0" descr=""/>
           <p:cNvGraphicFramePr/>
           <p:nvPr/>
         </p:nvGraphicFramePr>
@@ -12914,7 +12914,7 @@
       </p:graphicFrame>
       <p:sp>
         <p:nvSpPr>
-          <p:cNvPr id="5" name="Shape 2"/>
+          <p:cNvPr id="6" name="Shape 2"/>
           <p:cNvSpPr/>
           <p:nvPr/>
         </p:nvSpPr>
@@ -12936,7 +12936,7 @@
       </p:sp>
       <p:sp>
         <p:nvSpPr>
-          <p:cNvPr id="6" name="Text 3"/>
+          <p:cNvPr id="7" name="Text 3"/>
           <p:cNvSpPr txBox="1"/>
           <p:nvPr/>
         </p:nvSpPr>
@@ -12975,7 +12975,7 @@
       </p:sp>
       <p:sp>
         <p:nvSpPr>
-          <p:cNvPr id="7" name="Text 4"/>
+          <p:cNvPr id="8" name="Text 4"/>
           <p:cNvSpPr txBox="1"/>
           <p:nvPr/>
         </p:nvSpPr>
@@ -13031,7 +13031,7 @@
       </p:sp>
       <p:sp>
         <p:nvSpPr>
-          <p:cNvPr id="8" name="Shape 5"/>
+          <p:cNvPr id="9" name="Shape 5"/>
           <p:cNvSpPr/>
           <p:nvPr/>
         </p:nvSpPr>
@@ -13053,7 +13053,7 @@
       </p:sp>
       <p:sp>
         <p:nvSpPr>
-          <p:cNvPr id="9" name="Text 6"/>
+          <p:cNvPr id="10" name="Text 6"/>
           <p:cNvSpPr txBox="1"/>
           <p:nvPr/>
         </p:nvSpPr>
@@ -13092,7 +13092,7 @@
       </p:sp>
       <p:sp>
         <p:nvSpPr>
-          <p:cNvPr id="10" name="Text 7"/>
+          <p:cNvPr id="11" name="Text 7"/>
           <p:cNvSpPr txBox="1"/>
           <p:nvPr/>
         </p:nvSpPr>
@@ -13148,7 +13148,7 @@
       </p:sp>
       <p:sp>
         <p:nvSpPr>
-          <p:cNvPr id="11" name="Shape 8"/>
+          <p:cNvPr id="12" name="Shape 8"/>
           <p:cNvSpPr/>
           <p:nvPr/>
         </p:nvSpPr>
@@ -13170,7 +13170,7 @@
       </p:sp>
       <p:sp>
         <p:nvSpPr>
-          <p:cNvPr id="12" name="Text 9"/>
+          <p:cNvPr id="13" name="Text 9"/>
           <p:cNvSpPr txBox="1"/>
           <p:nvPr/>
         </p:nvSpPr>
@@ -13209,7 +13209,7 @@
       </p:sp>
       <p:sp>
         <p:nvSpPr>
-          <p:cNvPr id="13" name="Text 10"/>
+          <p:cNvPr id="14" name="Text 10"/>
           <p:cNvSpPr txBox="1"/>
           <p:nvPr/>
         </p:nvSpPr>
@@ -13265,7 +13265,7 @@
       </p:sp>
       <p:sp>
         <p:nvSpPr>
-          <p:cNvPr id="14" name="Text 11"/>
+          <p:cNvPr id="15" name="Text 11"/>
           <p:cNvSpPr txBox="1"/>
           <p:nvPr/>
         </p:nvSpPr>
@@ -13377,7 +13377,7 @@
       </p:grpSpPr>
       <p:sp>
         <p:nvSpPr>
-          <p:cNvPr id="2" name="Text 0"/>
+          <p:cNvPr id="3" name="Text 0"/>
           <p:cNvSpPr txBox="1"/>
           <p:nvPr/>
         </p:nvSpPr>
@@ -13416,7 +13416,7 @@
       </p:sp>
       <p:sp>
         <p:nvSpPr>
-          <p:cNvPr id="3" name="Text 1"/>
+          <p:cNvPr id="4" name="Text 1"/>
           <p:cNvSpPr txBox="1"/>
           <p:nvPr/>
         </p:nvSpPr>
@@ -13455,7 +13455,7 @@
       </p:sp>
       <p:sp>
         <p:nvSpPr>
-          <p:cNvPr id="4" name="Text 2"/>
+          <p:cNvPr id="5" name="Text 2"/>
           <p:cNvSpPr txBox="1"/>
           <p:nvPr/>
         </p:nvSpPr>
@@ -13494,7 +13494,7 @@
       </p:sp>
       <p:sp>
         <p:nvSpPr>
-          <p:cNvPr id="5" name="Shape 3"/>
+          <p:cNvPr id="6" name="Shape 3"/>
           <p:cNvSpPr/>
           <p:nvPr/>
         </p:nvSpPr>
@@ -13516,7 +13516,7 @@
       </p:sp>
       <p:sp>
         <p:nvSpPr>
-          <p:cNvPr id="6" name="Shape 4"/>
+          <p:cNvPr id="7" name="Shape 4"/>
           <p:cNvSpPr/>
           <p:nvPr/>
         </p:nvSpPr>
@@ -13538,7 +13538,7 @@
       </p:sp>
       <p:sp>
         <p:nvSpPr>
-          <p:cNvPr id="7" name="Text 5"/>
+          <p:cNvPr id="8" name="Text 5"/>
           <p:cNvSpPr txBox="1"/>
           <p:nvPr/>
         </p:nvSpPr>
@@ -13577,7 +13577,7 @@
       </p:sp>
       <p:sp>
         <p:nvSpPr>
-          <p:cNvPr id="8" name="Text 6"/>
+          <p:cNvPr id="9" name="Text 6"/>
           <p:cNvSpPr txBox="1"/>
           <p:nvPr/>
         </p:nvSpPr>
@@ -13616,7 +13616,7 @@
       </p:sp>
       <p:sp>
         <p:nvSpPr>
-          <p:cNvPr id="9" name="Shape 7"/>
+          <p:cNvPr id="10" name="Shape 7"/>
           <p:cNvSpPr/>
           <p:nvPr/>
         </p:nvSpPr>
@@ -13643,7 +13643,7 @@
       </p:sp>
       <p:sp>
         <p:nvSpPr>
-          <p:cNvPr id="10" name="Shape 8"/>
+          <p:cNvPr id="11" name="Shape 8"/>
           <p:cNvSpPr/>
           <p:nvPr/>
         </p:nvSpPr>
@@ -13665,7 +13665,7 @@
       </p:sp>
       <p:sp>
         <p:nvSpPr>
-          <p:cNvPr id="11" name="Text 9"/>
+          <p:cNvPr id="12" name="Text 9"/>
           <p:cNvSpPr txBox="1"/>
           <p:nvPr/>
         </p:nvSpPr>
@@ -13704,7 +13704,7 @@
       </p:sp>
       <p:sp>
         <p:nvSpPr>
-          <p:cNvPr id="12" name="Text 10"/>
+          <p:cNvPr id="13" name="Text 10"/>
           <p:cNvSpPr txBox="1"/>
           <p:nvPr/>
         </p:nvSpPr>
@@ -13743,7 +13743,7 @@
       </p:sp>
       <p:sp>
         <p:nvSpPr>
-          <p:cNvPr id="13" name="Shape 11"/>
+          <p:cNvPr id="14" name="Shape 11"/>
           <p:cNvSpPr/>
           <p:nvPr/>
         </p:nvSpPr>
@@ -13765,7 +13765,7 @@
       </p:sp>
       <p:sp>
         <p:nvSpPr>
-          <p:cNvPr id="14" name="Shape 12"/>
+          <p:cNvPr id="15" name="Shape 12"/>
           <p:cNvSpPr/>
           <p:nvPr/>
         </p:nvSpPr>
@@ -13787,7 +13787,7 @@
       </p:sp>
       <p:sp>
         <p:nvSpPr>
-          <p:cNvPr id="15" name="Text 13"/>
+          <p:cNvPr id="16" name="Text 13"/>
           <p:cNvSpPr txBox="1"/>
           <p:nvPr/>
         </p:nvSpPr>
@@ -13826,7 +13826,7 @@
       </p:sp>
       <p:sp>
         <p:nvSpPr>
-          <p:cNvPr id="16" name="Text 14"/>
+          <p:cNvPr id="17" name="Text 14"/>
           <p:cNvSpPr txBox="1"/>
           <p:nvPr/>
         </p:nvSpPr>
@@ -13865,7 +13865,7 @@
       </p:sp>
       <p:sp>
         <p:nvSpPr>
-          <p:cNvPr id="17" name="Shape 15"/>
+          <p:cNvPr id="18" name="Shape 15"/>
           <p:cNvSpPr/>
           <p:nvPr/>
         </p:nvSpPr>
@@ -13892,7 +13892,7 @@
       </p:sp>
       <p:sp>
         <p:nvSpPr>
-          <p:cNvPr id="18" name="Shape 16"/>
+          <p:cNvPr id="19" name="Shape 16"/>
           <p:cNvSpPr/>
           <p:nvPr/>
         </p:nvSpPr>
@@ -13914,7 +13914,7 @@
       </p:sp>
       <p:sp>
         <p:nvSpPr>
-          <p:cNvPr id="19" name="Text 17"/>
+          <p:cNvPr id="20" name="Text 17"/>
           <p:cNvSpPr txBox="1"/>
           <p:nvPr/>
         </p:nvSpPr>
@@ -13953,7 +13953,7 @@
       </p:sp>
       <p:sp>
         <p:nvSpPr>
-          <p:cNvPr id="20" name="Text 18"/>
+          <p:cNvPr id="21" name="Text 18"/>
           <p:cNvSpPr txBox="1"/>
           <p:nvPr/>
         </p:nvSpPr>
@@ -14065,7 +14065,7 @@
       </p:grpSpPr>
       <p:sp>
         <p:nvSpPr>
-          <p:cNvPr id="2" name="Text 0"/>
+          <p:cNvPr id="3" name="Text 0"/>
           <p:cNvSpPr txBox="1"/>
           <p:nvPr/>
         </p:nvSpPr>
@@ -14104,7 +14104,7 @@
       </p:sp>
       <p:sp>
         <p:nvSpPr>
-          <p:cNvPr id="3" name="Text 1"/>
+          <p:cNvPr id="4" name="Text 1"/>
           <p:cNvSpPr txBox="1"/>
           <p:nvPr/>
         </p:nvSpPr>
@@ -14143,7 +14143,7 @@
       </p:sp>
       <p:sp>
         <p:nvSpPr>
-          <p:cNvPr id="4" name="Shape 2"/>
+          <p:cNvPr id="5" name="Shape 2"/>
           <p:cNvSpPr/>
           <p:nvPr/>
         </p:nvSpPr>
@@ -14165,7 +14165,7 @@
       </p:sp>
       <p:sp>
         <p:nvSpPr>
-          <p:cNvPr id="5" name="Text 3"/>
+          <p:cNvPr id="6" name="Text 3"/>
           <p:cNvSpPr txBox="1"/>
           <p:nvPr/>
         </p:nvSpPr>
@@ -14204,7 +14204,7 @@
       </p:sp>
       <p:sp>
         <p:nvSpPr>
-          <p:cNvPr id="6" name="Shape 4"/>
+          <p:cNvPr id="7" name="Shape 4"/>
           <p:cNvSpPr/>
           <p:nvPr/>
         </p:nvSpPr>
@@ -14226,7 +14226,7 @@
       </p:sp>
       <p:sp>
         <p:nvSpPr>
-          <p:cNvPr id="7" name="Text 5"/>
+          <p:cNvPr id="8" name="Text 5"/>
           <p:cNvSpPr txBox="1"/>
           <p:nvPr/>
         </p:nvSpPr>
@@ -14282,7 +14282,7 @@
       </p:sp>
       <p:sp>
         <p:nvSpPr>
-          <p:cNvPr id="8" name="Text 6"/>
+          <p:cNvPr id="9" name="Text 6"/>
           <p:cNvSpPr txBox="1"/>
           <p:nvPr/>
         </p:nvSpPr>
@@ -14321,7 +14321,7 @@
       </p:sp>
       <p:sp>
         <p:nvSpPr>
-          <p:cNvPr id="9" name="Shape 7"/>
+          <p:cNvPr id="10" name="Shape 7"/>
           <p:cNvSpPr/>
           <p:nvPr/>
         </p:nvSpPr>
@@ -14343,7 +14343,7 @@
       </p:sp>
       <p:sp>
         <p:nvSpPr>
-          <p:cNvPr id="10" name="Text 8"/>
+          <p:cNvPr id="11" name="Text 8"/>
           <p:cNvSpPr txBox="1"/>
           <p:nvPr/>
         </p:nvSpPr>
@@ -14382,7 +14382,7 @@
       </p:sp>
       <p:sp>
         <p:nvSpPr>
-          <p:cNvPr id="11" name="Shape 9"/>
+          <p:cNvPr id="12" name="Shape 9"/>
           <p:cNvSpPr/>
           <p:nvPr/>
         </p:nvSpPr>
@@ -14404,7 +14404,7 @@
       </p:sp>
       <p:sp>
         <p:nvSpPr>
-          <p:cNvPr id="12" name="Text 10"/>
+          <p:cNvPr id="13" name="Text 10"/>
           <p:cNvSpPr txBox="1"/>
           <p:nvPr/>
         </p:nvSpPr>
@@ -14443,7 +14443,7 @@
       </p:sp>
       <p:sp>
         <p:nvSpPr>
-          <p:cNvPr id="13" name="Text 11"/>
+          <p:cNvPr id="14" name="Text 11"/>
           <p:cNvSpPr txBox="1"/>
           <p:nvPr/>
         </p:nvSpPr>
@@ -14482,7 +14482,7 @@
       </p:sp>
       <p:sp>
         <p:nvSpPr>
-          <p:cNvPr id="14" name="Shape 12"/>
+          <p:cNvPr id="15" name="Shape 12"/>
           <p:cNvSpPr/>
           <p:nvPr/>
         </p:nvSpPr>
@@ -14504,7 +14504,7 @@
       </p:sp>
       <p:sp>
         <p:nvSpPr>
-          <p:cNvPr id="15" name="Text 13"/>
+          <p:cNvPr id="16" name="Text 13"/>
           <p:cNvSpPr txBox="1"/>
           <p:nvPr/>
         </p:nvSpPr>
@@ -14543,7 +14543,7 @@
       </p:sp>
       <p:sp>
         <p:nvSpPr>
-          <p:cNvPr id="16" name="Shape 14"/>
+          <p:cNvPr id="17" name="Shape 14"/>
           <p:cNvSpPr/>
           <p:nvPr/>
         </p:nvSpPr>
@@ -14565,7 +14565,7 @@
       </p:sp>
       <p:sp>
         <p:nvSpPr>
-          <p:cNvPr id="17" name="Text 15"/>
+          <p:cNvPr id="18" name="Text 15"/>
           <p:cNvSpPr txBox="1"/>
           <p:nvPr/>
         </p:nvSpPr>
@@ -14604,7 +14604,7 @@
       </p:sp>
       <p:sp>
         <p:nvSpPr>
-          <p:cNvPr id="18" name="Text 16"/>
+          <p:cNvPr id="19" name="Text 16"/>
           <p:cNvSpPr txBox="1"/>
           <p:nvPr/>
         </p:nvSpPr>
@@ -14643,7 +14643,7 @@
       </p:sp>
       <p:sp>
         <p:nvSpPr>
-          <p:cNvPr id="19" name="Text 17"/>
+          <p:cNvPr id="20" name="Text 17"/>
           <p:cNvSpPr txBox="1"/>
           <p:nvPr/>
         </p:nvSpPr>
@@ -14755,7 +14755,7 @@
       </p:grpSpPr>
       <p:sp>
         <p:nvSpPr>
-          <p:cNvPr id="2" name="Text 0"/>
+          <p:cNvPr id="3" name="Text 0"/>
           <p:cNvSpPr txBox="1"/>
           <p:nvPr/>
         </p:nvSpPr>
@@ -14794,7 +14794,7 @@
       </p:sp>
       <p:sp>
         <p:nvSpPr>
-          <p:cNvPr id="3" name="Text 1"/>
+          <p:cNvPr id="4" name="Text 1"/>
           <p:cNvSpPr txBox="1"/>
           <p:nvPr/>
         </p:nvSpPr>
@@ -14833,7 +14833,7 @@
       </p:sp>
       <p:sp>
         <p:nvSpPr>
-          <p:cNvPr id="4" name="Shape 2"/>
+          <p:cNvPr id="5" name="Shape 2"/>
           <p:cNvSpPr/>
           <p:nvPr/>
         </p:nvSpPr>
@@ -14855,7 +14855,7 @@
       </p:sp>
       <p:sp>
         <p:nvSpPr>
-          <p:cNvPr id="5" name="Text 3"/>
+          <p:cNvPr id="6" name="Text 3"/>
           <p:cNvSpPr txBox="1"/>
           <p:nvPr/>
         </p:nvSpPr>
@@ -14989,7 +14989,7 @@
       </p:sp>
       <p:sp>
         <p:nvSpPr>
-          <p:cNvPr id="6" name="Shape 4"/>
+          <p:cNvPr id="7" name="Shape 4"/>
           <p:cNvSpPr/>
           <p:nvPr/>
         </p:nvSpPr>
@@ -15011,7 +15011,7 @@
       </p:sp>
       <p:sp>
         <p:nvSpPr>
-          <p:cNvPr id="7" name="Text 5"/>
+          <p:cNvPr id="8" name="Text 5"/>
           <p:cNvSpPr txBox="1"/>
           <p:nvPr/>
         </p:nvSpPr>
@@ -15050,7 +15050,7 @@
       </p:sp>
       <p:sp>
         <p:nvSpPr>
-          <p:cNvPr id="8" name="Text 6"/>
+          <p:cNvPr id="9" name="Text 6"/>
           <p:cNvSpPr txBox="1"/>
           <p:nvPr/>
         </p:nvSpPr>
@@ -15131,7 +15131,7 @@
       </p:sp>
       <p:sp>
         <p:nvSpPr>
-          <p:cNvPr id="9" name="Shape 7"/>
+          <p:cNvPr id="10" name="Shape 7"/>
           <p:cNvSpPr/>
           <p:nvPr/>
         </p:nvSpPr>
@@ -15153,7 +15153,7 @@
       </p:sp>
       <p:sp>
         <p:nvSpPr>
-          <p:cNvPr id="10" name="Text 8"/>
+          <p:cNvPr id="11" name="Text 8"/>
           <p:cNvSpPr txBox="1"/>
           <p:nvPr/>
         </p:nvSpPr>
@@ -15192,7 +15192,7 @@
       </p:sp>
       <p:sp>
         <p:nvSpPr>
-          <p:cNvPr id="11" name="Text 9"/>
+          <p:cNvPr id="12" name="Text 9"/>
           <p:cNvSpPr txBox="1"/>
           <p:nvPr/>
         </p:nvSpPr>
@@ -15248,7 +15248,7 @@
       </p:sp>
       <p:sp>
         <p:nvSpPr>
-          <p:cNvPr id="12" name="Text 10"/>
+          <p:cNvPr id="13" name="Text 10"/>
           <p:cNvSpPr txBox="1"/>
           <p:nvPr/>
         </p:nvSpPr>
@@ -15360,7 +15360,7 @@
       </p:grpSpPr>
       <p:sp>
         <p:nvSpPr>
-          <p:cNvPr id="2" name="Text 0"/>
+          <p:cNvPr id="3" name="Text 0"/>
           <p:cNvSpPr txBox="1"/>
           <p:nvPr/>
         </p:nvSpPr>
@@ -15399,7 +15399,7 @@
       </p:sp>
       <p:sp>
         <p:nvSpPr>
-          <p:cNvPr id="3" name="Text 1"/>
+          <p:cNvPr id="4" name="Text 1"/>
           <p:cNvSpPr txBox="1"/>
           <p:nvPr/>
         </p:nvSpPr>
@@ -15438,7 +15438,7 @@
       </p:sp>
       <p:sp>
         <p:nvSpPr>
-          <p:cNvPr id="4" name="Shape 2"/>
+          <p:cNvPr id="5" name="Shape 2"/>
           <p:cNvSpPr/>
           <p:nvPr/>
         </p:nvSpPr>
@@ -15460,7 +15460,7 @@
       </p:sp>
       <p:sp>
         <p:nvSpPr>
-          <p:cNvPr id="5" name="Shape 3"/>
+          <p:cNvPr id="6" name="Shape 3"/>
           <p:cNvSpPr/>
           <p:nvPr/>
         </p:nvSpPr>
@@ -15480,7 +15480,7 @@
       </p:sp>
       <p:sp>
         <p:nvSpPr>
-          <p:cNvPr id="6" name="Text 4"/>
+          <p:cNvPr id="7" name="Text 4"/>
           <p:cNvSpPr txBox="1"/>
           <p:nvPr/>
         </p:nvSpPr>
@@ -15519,7 +15519,7 @@
       </p:sp>
       <p:sp>
         <p:nvSpPr>
-          <p:cNvPr id="7" name="Text 5"/>
+          <p:cNvPr id="8" name="Text 5"/>
           <p:cNvSpPr txBox="1"/>
           <p:nvPr/>
         </p:nvSpPr>
@@ -15558,7 +15558,7 @@
       </p:sp>
       <p:sp>
         <p:nvSpPr>
-          <p:cNvPr id="8" name="Text 6"/>
+          <p:cNvPr id="9" name="Text 6"/>
           <p:cNvSpPr txBox="1"/>
           <p:nvPr/>
         </p:nvSpPr>
@@ -15597,7 +15597,7 @@
       </p:sp>
       <p:sp>
         <p:nvSpPr>
-          <p:cNvPr id="9" name="Text 7"/>
+          <p:cNvPr id="10" name="Text 7"/>
           <p:cNvSpPr txBox="1"/>
           <p:nvPr/>
         </p:nvSpPr>
@@ -15636,7 +15636,7 @@
       </p:sp>
       <p:sp>
         <p:nvSpPr>
-          <p:cNvPr id="10" name="Shape 8"/>
+          <p:cNvPr id="11" name="Shape 8"/>
           <p:cNvSpPr/>
           <p:nvPr/>
         </p:nvSpPr>
@@ -15658,7 +15658,7 @@
       </p:sp>
       <p:sp>
         <p:nvSpPr>
-          <p:cNvPr id="11" name="Shape 9"/>
+          <p:cNvPr id="12" name="Shape 9"/>
           <p:cNvSpPr/>
           <p:nvPr/>
         </p:nvSpPr>
@@ -15678,7 +15678,7 @@
       </p:sp>
       <p:sp>
         <p:nvSpPr>
-          <p:cNvPr id="12" name="Text 10"/>
+          <p:cNvPr id="13" name="Text 10"/>
           <p:cNvSpPr txBox="1"/>
           <p:nvPr/>
         </p:nvSpPr>
@@ -15717,7 +15717,7 @@
       </p:sp>
       <p:sp>
         <p:nvSpPr>
-          <p:cNvPr id="13" name="Text 11"/>
+          <p:cNvPr id="14" name="Text 11"/>
           <p:cNvSpPr txBox="1"/>
           <p:nvPr/>
         </p:nvSpPr>
@@ -15756,7 +15756,7 @@
       </p:sp>
       <p:sp>
         <p:nvSpPr>
-          <p:cNvPr id="14" name="Text 12"/>
+          <p:cNvPr id="15" name="Text 12"/>
           <p:cNvSpPr txBox="1"/>
           <p:nvPr/>
         </p:nvSpPr>
@@ -15795,7 +15795,7 @@
       </p:sp>
       <p:sp>
         <p:nvSpPr>
-          <p:cNvPr id="15" name="Text 13"/>
+          <p:cNvPr id="16" name="Text 13"/>
           <p:cNvSpPr txBox="1"/>
           <p:nvPr/>
         </p:nvSpPr>
@@ -15834,7 +15834,7 @@
       </p:sp>
       <p:sp>
         <p:nvSpPr>
-          <p:cNvPr id="16" name="Shape 14"/>
+          <p:cNvPr id="17" name="Shape 14"/>
           <p:cNvSpPr/>
           <p:nvPr/>
         </p:nvSpPr>
@@ -15856,7 +15856,7 @@
       </p:sp>
       <p:sp>
         <p:nvSpPr>
-          <p:cNvPr id="17" name="Shape 15"/>
+          <p:cNvPr id="18" name="Shape 15"/>
           <p:cNvSpPr/>
           <p:nvPr/>
         </p:nvSpPr>
@@ -15876,7 +15876,7 @@
       </p:sp>
       <p:sp>
         <p:nvSpPr>
-          <p:cNvPr id="18" name="Text 16"/>
+          <p:cNvPr id="19" name="Text 16"/>
           <p:cNvSpPr txBox="1"/>
           <p:nvPr/>
         </p:nvSpPr>
@@ -15915,7 +15915,7 @@
       </p:sp>
       <p:sp>
         <p:nvSpPr>
-          <p:cNvPr id="19" name="Text 17"/>
+          <p:cNvPr id="20" name="Text 17"/>
           <p:cNvSpPr txBox="1"/>
           <p:nvPr/>
         </p:nvSpPr>
@@ -15954,7 +15954,7 @@
       </p:sp>
       <p:sp>
         <p:nvSpPr>
-          <p:cNvPr id="20" name="Text 18"/>
+          <p:cNvPr id="21" name="Text 18"/>
           <p:cNvSpPr txBox="1"/>
           <p:nvPr/>
         </p:nvSpPr>
@@ -15993,7 +15993,7 @@
       </p:sp>
       <p:sp>
         <p:nvSpPr>
-          <p:cNvPr id="21" name="Text 19"/>
+          <p:cNvPr id="22" name="Text 19"/>
           <p:cNvSpPr txBox="1"/>
           <p:nvPr/>
         </p:nvSpPr>
@@ -16032,7 +16032,7 @@
       </p:sp>
       <p:sp>
         <p:nvSpPr>
-          <p:cNvPr id="22" name="Shape 20"/>
+          <p:cNvPr id="23" name="Shape 20"/>
           <p:cNvSpPr/>
           <p:nvPr/>
         </p:nvSpPr>
@@ -16054,7 +16054,7 @@
       </p:sp>
       <p:sp>
         <p:nvSpPr>
-          <p:cNvPr id="23" name="Text 21"/>
+          <p:cNvPr id="24" name="Text 21"/>
           <p:cNvSpPr txBox="1"/>
           <p:nvPr/>
         </p:nvSpPr>

</xml_diff>